<commit_message>
[Documentation] Sync Midterm deck with the HW5 deliverable
- Replace the simulated terminal text on demo snapshot slides 7–9 with
  the real PNG captures (build-success, sample-project-check,
  suppress-demo, json-output-demo) committed in 9a972d3
- Switch SSD / SD on slides 12–14 to the HW5 renders that carry
  activation bars, GRASP labels, and the UC-03 Abort branch
- Embed the redrawn Domain-Layer-only Implementation Class Diagram on
  slide 16 and shrink the Δ table to the Domain rows that are actually
  visible in the figure; the Application/Infrastructure delta is
  already on §4.3 Table 4.3.1
- Replace simulated mvn output on slide 18 with the test-result.png
  snapshot
- Catch up to the rename refactor: domain.constraint→domain.rule,
  constraintId→ruleId, "標的某 Constraint"→ComplianceRule,
  "Repository 隱藏 YAML I/O"→SuppressionStore, NamingRuleTest path
</commit_message>
<xml_diff>
--- a/hw/Midterm/midterm-team6.pptx
+++ b/hw/Midterm/midterm-team6.pptx
@@ -3904,7 +3904,7 @@
                 <a:ea typeface="Microsoft JhengHei" pitchFamily="34" charset="-122"/>
                 <a:cs typeface="Microsoft JhengHei" pitchFamily="34" charset="-120"/>
               </a:rPr>
-              <a:t>StyleProfile — 持有 1..* 個 ArchitectureConstraint</a:t>
+              <a:t>StyleProfile — 持有 1..* 個 ComplianceRule</a:t>
             </a:r>
             <a:endParaRPr lang="en-US" sz="1100" dirty="0"/>
           </a:p>
@@ -3925,7 +3925,7 @@
                 <a:ea typeface="Microsoft JhengHei" pitchFamily="34" charset="-122"/>
                 <a:cs typeface="Microsoft JhengHei" pitchFamily="34" charset="-120"/>
               </a:rPr>
-              <a:t>ArchitectureConstraint (abstract) → 4 個具體規則</a:t>
+              <a:t>ComplianceRule (abstract) → 4 個具體規則</a:t>
             </a:r>
             <a:endParaRPr lang="en-US" sz="1100" dirty="0"/>
           </a:p>
@@ -3988,7 +3988,7 @@
                 <a:ea typeface="Microsoft JhengHei" pitchFamily="34" charset="-122"/>
                 <a:cs typeface="Microsoft JhengHei" pitchFamily="34" charset="-120"/>
               </a:rPr>
-              <a:t>Suppression — 標的某 Constraint，下次執行被忽略</a:t>
+              <a:t>Suppression — 標的某 ComplianceRule，下次執行被忽略</a:t>
             </a:r>
             <a:endParaRPr lang="en-US" sz="1100" dirty="0"/>
           </a:p>
@@ -4518,7 +4518,7 @@
                 <a:ea typeface="Microsoft JhengHei" pitchFamily="34" charset="-122"/>
                 <a:cs typeface="Microsoft JhengHei" pitchFamily="34" charset="-120"/>
               </a:rPr>
-              <a:t>use case services 與技術介面（ports）：CodeParser、ProfileRepository、SuppressionRepository、Reporter</a:t>
+              <a:t>use case services 與技術介面（ports）：CodeParser、ProfileLoader、SuppressionStore、Reporter</a:t>
             </a:r>
             <a:endParaRPr lang="en-US" sz="1100" dirty="0"/>
           </a:p>
@@ -4621,7 +4621,7 @@
                 <a:ea typeface="Microsoft JhengHei" pitchFamily="34" charset="-122"/>
                 <a:cs typeface="Microsoft JhengHei" pitchFamily="34" charset="-120"/>
               </a:rPr>
-              <a:t>4 個 sub-package — constraint、profile、codebase、compliance — 純業務模型 + 多型 validate(files)</a:t>
+              <a:t>4 個 sub-package — rule、profile、codebase、compliance — 純業務模型 + 多型 validate(files)</a:t>
             </a:r>
             <a:endParaRPr lang="en-US" sz="1100" dirty="0"/>
           </a:p>
@@ -4724,7 +4724,7 @@
                 <a:ea typeface="Microsoft JhengHei" pitchFamily="34" charset="-122"/>
                 <a:cs typeface="Microsoft JhengHei" pitchFamily="34" charset="-120"/>
               </a:rPr>
-              <a:t>實作 ports 的 adapters：JavaParserAdapter、YamlProfileRepository、ConsoleReporter / JsonReporter、YamlSuppressionRepository</a:t>
+              <a:t>實作 ports 的 adapters：JavaParserAdapter、YamlProfileLoader、ConsoleReporter / JsonReporter、YamlSuppressionStore</a:t>
             </a:r>
             <a:endParaRPr lang="en-US" sz="1100" dirty="0"/>
           </a:p>
@@ -4993,7 +4993,7 @@
       </p:sp>
       <p:pic>
         <p:nvPicPr>
-          <p:cNvPr id="9" name="Image 0" descr="..\hw4\images\3.2.1-uc01-ssd.png">    </p:cNvPr>
+          <p:cNvPr id="9" name="Image 0" descr="..\hw5\images\3.2.1-uc01-ssd.png">    </p:cNvPr>
           <p:cNvPicPr>
             <a:picLocks noChangeAspect="1"/>
           </p:cNvPicPr>
@@ -5539,7 +5539,7 @@
       </p:sp>
       <p:pic>
         <p:nvPicPr>
-          <p:cNvPr id="9" name="Image 0" descr="..\hw4\images\3.2.1-uc01-sd.png">    </p:cNvPr>
+          <p:cNvPr id="9" name="Image 0" descr="..\hw5\images\3.2.1-uc01-sd.png">    </p:cNvPr>
           <p:cNvPicPr>
             <a:picLocks noChangeAspect="1"/>
           </p:cNvPicPr>
@@ -5553,8 +5553,8 @@
         </p:blipFill>
         <p:spPr>
           <a:xfrm>
-            <a:off x="3559937" y="914400"/>
-            <a:ext cx="5071820" cy="3520440"/>
+            <a:off x="2948421" y="914400"/>
+            <a:ext cx="6294853" cy="3520440"/>
           </a:xfrm>
           <a:prstGeom prst="rect">
             <a:avLst/>
@@ -6139,7 +6139,7 @@
                           <a:ea typeface="Microsoft JhengHei" pitchFamily="34" charset="-122"/>
                           <a:cs typeface="Microsoft JhengHei" pitchFamily="34" charset="-120"/>
                         </a:rPr>
-                        <a:t>主導檢查流程，整合 Profile + Files + Constraints</a:t>
+                        <a:t>主導檢查流程，整合 Profile + Files + ComplianceRules</a:t>
                       </a:r>
                       <a:endParaRPr lang="en-US" sz="900" dirty="0">
                         <a:latin typeface="Microsoft JhengHei" charset="0"/>
@@ -6271,7 +6271,7 @@
                           <a:ea typeface="Microsoft JhengHei" pitchFamily="34" charset="-122"/>
                           <a:cs typeface="Microsoft JhengHei" pitchFamily="34" charset="-120"/>
                         </a:rPr>
-                        <a:t>ArchitectureConstraint</a:t>
+                        <a:t>ComplianceRule</a:t>
                       </a:r>
                       <a:endParaRPr lang="en-US" sz="900" dirty="0">
                         <a:latin typeface="Microsoft JhengHei" charset="0"/>
@@ -6468,7 +6468,7 @@
                           <a:ea typeface="Microsoft JhengHei" pitchFamily="34" charset="-122"/>
                           <a:cs typeface="Microsoft JhengHei" pitchFamily="34" charset="-120"/>
                         </a:rPr>
-                        <a:t>:Adapter / :Repository</a:t>
+                        <a:t>:Adapter / :Store</a:t>
                       </a:r>
                       <a:endParaRPr lang="en-US" sz="900" dirty="0">
                         <a:latin typeface="Microsoft JhengHei" charset="0"/>
@@ -6533,7 +6533,7 @@
                           <a:ea typeface="Microsoft JhengHei" pitchFamily="34" charset="-122"/>
                           <a:cs typeface="Microsoft JhengHei" pitchFamily="34" charset="-120"/>
                         </a:rPr>
-                        <a:t>JavaParser、YAML 等技術隔離於 ports（CodeParser、ProfileRepository …）</a:t>
+                        <a:t>JavaParser、YAML 等技術隔離於 ports（CodeParser、ProfileLoader …）</a:t>
                       </a:r>
                       <a:endParaRPr lang="en-US" sz="900" dirty="0">
                         <a:latin typeface="Microsoft JhengHei" charset="0"/>
@@ -7046,7 +7046,7 @@
       </p:sp>
       <p:pic>
         <p:nvPicPr>
-          <p:cNvPr id="9" name="Image 0" descr="..\hw4\images\3.2.3-uc04-ssd.png">    </p:cNvPr>
+          <p:cNvPr id="9" name="Image 0" descr="..\hw5\images\3.2.3-uc04-ssd.png">    </p:cNvPr>
           <p:cNvPicPr>
             <a:picLocks noChangeAspect="1"/>
           </p:cNvPicPr>
@@ -7109,7 +7109,7 @@
       </p:sp>
       <p:pic>
         <p:nvPicPr>
-          <p:cNvPr id="11" name="Image 1" descr="..\hw4\images\3.2.3-uc04-sd.png">    </p:cNvPr>
+          <p:cNvPr id="11" name="Image 1" descr="..\hw5\images\3.2.3-uc04-sd.png">    </p:cNvPr>
           <p:cNvPicPr>
             <a:picLocks noChangeAspect="1"/>
           </p:cNvPicPr>
@@ -7124,7 +7124,7 @@
         <p:spPr>
           <a:xfrm>
             <a:off x="5669280" y="1005840"/>
-            <a:ext cx="4828032" cy="4023360"/>
+            <a:ext cx="6400800" cy="3577450"/>
           </a:xfrm>
           <a:prstGeom prst="rect">
             <a:avLst/>
@@ -7139,8 +7139,8 @@
         </p:nvSpPr>
         <p:spPr>
           <a:xfrm>
-            <a:off x="5669280" y="5074920"/>
-            <a:ext cx="4828032" cy="274320"/>
+            <a:off x="5669280" y="4629010"/>
+            <a:ext cx="6400800" cy="274320"/>
           </a:xfrm>
           <a:prstGeom prst="rect">
             <a:avLst/>
@@ -7880,7 +7880,7 @@
                           <a:ea typeface="Microsoft JhengHei" pitchFamily="34" charset="-122"/>
                           <a:cs typeface="Microsoft JhengHei" pitchFamily="34" charset="-120"/>
                         </a:rPr>
-                        <a:t>:SuppressionRepository</a:t>
+                        <a:t>:SuppressionStore</a:t>
                       </a:r>
                       <a:endParaRPr lang="en-US" sz="1000" dirty="0">
                         <a:latin typeface="Microsoft JhengHei" charset="0"/>
@@ -8400,7 +8400,7 @@
                 <a:ea typeface="Microsoft JhengHei" pitchFamily="34" charset="-122"/>
                 <a:cs typeface="Microsoft JhengHei" pitchFamily="34" charset="-120"/>
               </a:rPr>
-              <a:t>ArchitectureConstraint 升級為 </a:t>
+              <a:t>ComplianceRule 升級為 </a:t>
             </a:r>
             <a:pPr indent="0" marL="0">
               <a:spcAft>
@@ -8875,7 +8875,7 @@
         <p:spPr>
           <a:xfrm>
             <a:off x="502920" y="1005840"/>
-            <a:ext cx="4655127" cy="5120640"/>
+            <a:ext cx="6962637" cy="5120640"/>
           </a:xfrm>
           <a:prstGeom prst="rect">
             <a:avLst/>
@@ -8890,8 +8890,8 @@
         </p:nvSpPr>
         <p:spPr>
           <a:xfrm>
-            <a:off x="8961120" y="1005840"/>
-            <a:ext cx="3108960" cy="292608"/>
+            <a:off x="8595360" y="1005840"/>
+            <a:ext cx="3383280" cy="292608"/>
           </a:xfrm>
           <a:prstGeom prst="rect">
             <a:avLst/>
@@ -8907,7 +8907,7 @@
               <a:buNone/>
             </a:pPr>
             <a:r>
-              <a:rPr lang="en-US" sz="1400" b="1" dirty="0">
+              <a:rPr lang="en-US" sz="1300" b="1" dirty="0">
                 <a:solidFill>
                   <a:srgbClr val="1E2761"/>
                 </a:solidFill>
@@ -8915,9 +8915,9 @@
                 <a:ea typeface="Microsoft JhengHei" pitchFamily="34" charset="-122"/>
                 <a:cs typeface="Microsoft JhengHei" pitchFamily="34" charset="-120"/>
               </a:rPr>
-              <a:t>Δ Implementation vs DCD</a:t>
-            </a:r>
-            <a:endParaRPr lang="en-US" sz="1400" dirty="0"/>
+              <a:t>Δ Implementation vs DCD（Domain Layer）</a:t>
+            </a:r>
+            <a:endParaRPr lang="en-US" sz="1300" dirty="0"/>
           </a:p>
         </p:txBody>
       </p:sp>
@@ -8936,18 +8936,18 @@
           </p:nvPr>
         </p:nvGraphicFramePr>
         <p:xfrm>
-          <a:off x="8961120" y="1371600"/>
-          <a:ext cx="3108960" cy="914400"/>
+          <a:off x="8595360" y="1371600"/>
+          <a:ext cx="3383280" cy="914400"/>
         </p:xfrm>
         <a:graphic>
           <a:graphicData uri="http://schemas.openxmlformats.org/drawingml/2006/table">
             <a:tbl>
               <a:tblPr/>
               <a:tblGrid>
-                <a:gridCol w="1645920"/>
-                <a:gridCol w="502920"/>
+                <a:gridCol w="1828800"/>
+                <a:gridCol w="548640"/>
                 <a:gridCol w="457200"/>
-                <a:gridCol w="502920"/>
+                <a:gridCol w="548640"/>
               </a:tblGrid>
               <a:tr h="0">
                 <a:tc>
@@ -9747,530 +9747,6 @@
                   </a:tcPr>
                 </a:tc>
               </a:tr>
-              <a:tr h="0">
-                <a:tc>
-                  <a:txBody>
-                    <a:bodyPr/>
-                    <a:lstStyle/>
-                    <a:p>
-                      <a:pPr indent="0" marL="0">
-                        <a:buNone/>
-                      </a:pPr>
-                      <a:r>
-                        <a:rPr lang="en-US" sz="1000" dirty="0">
-                          <a:solidFill>
-                            <a:srgbClr val="1F2A44"/>
-                          </a:solidFill>
-                          <a:latin typeface="Microsoft JhengHei" pitchFamily="34" charset="0"/>
-                          <a:ea typeface="Microsoft JhengHei" pitchFamily="34" charset="-122"/>
-                          <a:cs typeface="Microsoft JhengHei" pitchFamily="34" charset="-120"/>
-                        </a:rPr>
-                        <a:t>Non-domain · class（HW5 新增）</a:t>
-                      </a:r>
-                      <a:endParaRPr lang="en-US" sz="1000" dirty="0">
-                        <a:latin typeface="Microsoft JhengHei" charset="0"/>
-                        <a:ea typeface="Microsoft JhengHei" charset="0"/>
-                        <a:cs typeface="Microsoft JhengHei" charset="0"/>
-                      </a:endParaRPr>
-                    </a:p>
-                  </a:txBody>
-                  <a:tcPr marL="91440" marR="91440" marT="45720" marB="45720">
-                    <a:lnL w="6350" cap="flat" cmpd="sng" algn="ctr">
-                      <a:solidFill>
-                        <a:srgbClr val="D4DBE8"/>
-                      </a:solidFill>
-                      <a:prstDash val="solid"/>
-                      <a:round/>
-                      <a:headEnd type="none" w="med" len="med"/>
-                      <a:tailEnd type="none" w="med" len="med"/>
-                    </a:lnL>
-                    <a:lnR w="6350" cap="flat" cmpd="sng" algn="ctr">
-                      <a:solidFill>
-                        <a:srgbClr val="D4DBE8"/>
-                      </a:solidFill>
-                      <a:prstDash val="solid"/>
-                      <a:round/>
-                      <a:headEnd type="none" w="med" len="med"/>
-                      <a:tailEnd type="none" w="med" len="med"/>
-                    </a:lnR>
-                    <a:lnT w="6350" cap="flat" cmpd="sng" algn="ctr">
-                      <a:solidFill>
-                        <a:srgbClr val="D4DBE8"/>
-                      </a:solidFill>
-                      <a:prstDash val="solid"/>
-                      <a:round/>
-                      <a:headEnd type="none" w="med" len="med"/>
-                      <a:tailEnd type="none" w="med" len="med"/>
-                    </a:lnT>
-                    <a:lnB w="6350" cap="flat" cmpd="sng" algn="ctr">
-                      <a:solidFill>
-                        <a:srgbClr val="D4DBE8"/>
-                      </a:solidFill>
-                      <a:prstDash val="solid"/>
-                      <a:round/>
-                      <a:headEnd type="none" w="med" len="med"/>
-                      <a:tailEnd type="none" w="med" len="med"/>
-                    </a:lnB>
-                  </a:tcPr>
-                </a:tc>
-                <a:tc>
-                  <a:txBody>
-                    <a:bodyPr/>
-                    <a:lstStyle/>
-                    <a:p>
-                      <a:pPr algn="ctr" indent="0" marL="0">
-                        <a:buNone/>
-                      </a:pPr>
-                      <a:r>
-                        <a:rPr lang="en-US" sz="1000" b="1" dirty="0">
-                          <a:solidFill>
-                            <a:srgbClr val="1C7293"/>
-                          </a:solidFill>
-                          <a:latin typeface="Microsoft JhengHei" pitchFamily="34" charset="0"/>
-                          <a:ea typeface="Microsoft JhengHei" pitchFamily="34" charset="-122"/>
-                          <a:cs typeface="Microsoft JhengHei" pitchFamily="34" charset="-120"/>
-                        </a:rPr>
-                        <a:t>14</a:t>
-                      </a:r>
-                      <a:endParaRPr lang="en-US" sz="1000" dirty="0">
-                        <a:latin typeface="Microsoft JhengHei" charset="0"/>
-                        <a:ea typeface="Microsoft JhengHei" charset="0"/>
-                        <a:cs typeface="Microsoft JhengHei" charset="0"/>
-                      </a:endParaRPr>
-                    </a:p>
-                  </a:txBody>
-                  <a:tcPr marL="91440" marR="91440" marT="45720" marB="45720">
-                    <a:lnL w="6350" cap="flat" cmpd="sng" algn="ctr">
-                      <a:solidFill>
-                        <a:srgbClr val="D4DBE8"/>
-                      </a:solidFill>
-                      <a:prstDash val="solid"/>
-                      <a:round/>
-                      <a:headEnd type="none" w="med" len="med"/>
-                      <a:tailEnd type="none" w="med" len="med"/>
-                    </a:lnL>
-                    <a:lnR w="6350" cap="flat" cmpd="sng" algn="ctr">
-                      <a:solidFill>
-                        <a:srgbClr val="D4DBE8"/>
-                      </a:solidFill>
-                      <a:prstDash val="solid"/>
-                      <a:round/>
-                      <a:headEnd type="none" w="med" len="med"/>
-                      <a:tailEnd type="none" w="med" len="med"/>
-                    </a:lnR>
-                    <a:lnT w="6350" cap="flat" cmpd="sng" algn="ctr">
-                      <a:solidFill>
-                        <a:srgbClr val="D4DBE8"/>
-                      </a:solidFill>
-                      <a:prstDash val="solid"/>
-                      <a:round/>
-                      <a:headEnd type="none" w="med" len="med"/>
-                      <a:tailEnd type="none" w="med" len="med"/>
-                    </a:lnT>
-                    <a:lnB w="6350" cap="flat" cmpd="sng" algn="ctr">
-                      <a:solidFill>
-                        <a:srgbClr val="D4DBE8"/>
-                      </a:solidFill>
-                      <a:prstDash val="solid"/>
-                      <a:round/>
-                      <a:headEnd type="none" w="med" len="med"/>
-                      <a:tailEnd type="none" w="med" len="med"/>
-                    </a:lnB>
-                  </a:tcPr>
-                </a:tc>
-                <a:tc>
-                  <a:txBody>
-                    <a:bodyPr/>
-                    <a:lstStyle/>
-                    <a:p>
-                      <a:pPr algn="ctr" indent="0" marL="0">
-                        <a:buNone/>
-                      </a:pPr>
-                      <a:r>
-                        <a:rPr lang="en-US" sz="1000" dirty="0">
-                          <a:solidFill>
-                            <a:srgbClr val="1F2A44"/>
-                          </a:solidFill>
-                          <a:latin typeface="Microsoft JhengHei" pitchFamily="34" charset="0"/>
-                          <a:ea typeface="Microsoft JhengHei" pitchFamily="34" charset="-122"/>
-                          <a:cs typeface="Microsoft JhengHei" pitchFamily="34" charset="-120"/>
-                        </a:rPr>
-                        <a:t>0</a:t>
-                      </a:r>
-                      <a:endParaRPr lang="en-US" sz="1000" dirty="0">
-                        <a:latin typeface="Microsoft JhengHei" charset="0"/>
-                        <a:ea typeface="Microsoft JhengHei" charset="0"/>
-                        <a:cs typeface="Microsoft JhengHei" charset="0"/>
-                      </a:endParaRPr>
-                    </a:p>
-                  </a:txBody>
-                  <a:tcPr marL="91440" marR="91440" marT="45720" marB="45720">
-                    <a:lnL w="6350" cap="flat" cmpd="sng" algn="ctr">
-                      <a:solidFill>
-                        <a:srgbClr val="D4DBE8"/>
-                      </a:solidFill>
-                      <a:prstDash val="solid"/>
-                      <a:round/>
-                      <a:headEnd type="none" w="med" len="med"/>
-                      <a:tailEnd type="none" w="med" len="med"/>
-                    </a:lnL>
-                    <a:lnR w="6350" cap="flat" cmpd="sng" algn="ctr">
-                      <a:solidFill>
-                        <a:srgbClr val="D4DBE8"/>
-                      </a:solidFill>
-                      <a:prstDash val="solid"/>
-                      <a:round/>
-                      <a:headEnd type="none" w="med" len="med"/>
-                      <a:tailEnd type="none" w="med" len="med"/>
-                    </a:lnR>
-                    <a:lnT w="6350" cap="flat" cmpd="sng" algn="ctr">
-                      <a:solidFill>
-                        <a:srgbClr val="D4DBE8"/>
-                      </a:solidFill>
-                      <a:prstDash val="solid"/>
-                      <a:round/>
-                      <a:headEnd type="none" w="med" len="med"/>
-                      <a:tailEnd type="none" w="med" len="med"/>
-                    </a:lnT>
-                    <a:lnB w="6350" cap="flat" cmpd="sng" algn="ctr">
-                      <a:solidFill>
-                        <a:srgbClr val="D4DBE8"/>
-                      </a:solidFill>
-                      <a:prstDash val="solid"/>
-                      <a:round/>
-                      <a:headEnd type="none" w="med" len="med"/>
-                      <a:tailEnd type="none" w="med" len="med"/>
-                    </a:lnB>
-                  </a:tcPr>
-                </a:tc>
-                <a:tc>
-                  <a:txBody>
-                    <a:bodyPr/>
-                    <a:lstStyle/>
-                    <a:p>
-                      <a:pPr algn="ctr" indent="0" marL="0">
-                        <a:buNone/>
-                      </a:pPr>
-                      <a:r>
-                        <a:rPr lang="en-US" sz="1000" dirty="0">
-                          <a:solidFill>
-                            <a:srgbClr val="1F2A44"/>
-                          </a:solidFill>
-                          <a:latin typeface="Microsoft JhengHei" pitchFamily="34" charset="0"/>
-                          <a:ea typeface="Microsoft JhengHei" pitchFamily="34" charset="-122"/>
-                          <a:cs typeface="Microsoft JhengHei" pitchFamily="34" charset="-120"/>
-                        </a:rPr>
-                        <a:t>0</a:t>
-                      </a:r>
-                      <a:endParaRPr lang="en-US" sz="1000" dirty="0">
-                        <a:latin typeface="Microsoft JhengHei" charset="0"/>
-                        <a:ea typeface="Microsoft JhengHei" charset="0"/>
-                        <a:cs typeface="Microsoft JhengHei" charset="0"/>
-                      </a:endParaRPr>
-                    </a:p>
-                  </a:txBody>
-                  <a:tcPr marL="91440" marR="91440" marT="45720" marB="45720">
-                    <a:lnL w="6350" cap="flat" cmpd="sng" algn="ctr">
-                      <a:solidFill>
-                        <a:srgbClr val="D4DBE8"/>
-                      </a:solidFill>
-                      <a:prstDash val="solid"/>
-                      <a:round/>
-                      <a:headEnd type="none" w="med" len="med"/>
-                      <a:tailEnd type="none" w="med" len="med"/>
-                    </a:lnL>
-                    <a:lnR w="6350" cap="flat" cmpd="sng" algn="ctr">
-                      <a:solidFill>
-                        <a:srgbClr val="D4DBE8"/>
-                      </a:solidFill>
-                      <a:prstDash val="solid"/>
-                      <a:round/>
-                      <a:headEnd type="none" w="med" len="med"/>
-                      <a:tailEnd type="none" w="med" len="med"/>
-                    </a:lnR>
-                    <a:lnT w="6350" cap="flat" cmpd="sng" algn="ctr">
-                      <a:solidFill>
-                        <a:srgbClr val="D4DBE8"/>
-                      </a:solidFill>
-                      <a:prstDash val="solid"/>
-                      <a:round/>
-                      <a:headEnd type="none" w="med" len="med"/>
-                      <a:tailEnd type="none" w="med" len="med"/>
-                    </a:lnT>
-                    <a:lnB w="6350" cap="flat" cmpd="sng" algn="ctr">
-                      <a:solidFill>
-                        <a:srgbClr val="D4DBE8"/>
-                      </a:solidFill>
-                      <a:prstDash val="solid"/>
-                      <a:round/>
-                      <a:headEnd type="none" w="med" len="med"/>
-                      <a:tailEnd type="none" w="med" len="med"/>
-                    </a:lnB>
-                  </a:tcPr>
-                </a:tc>
-              </a:tr>
-              <a:tr h="0">
-                <a:tc>
-                  <a:txBody>
-                    <a:bodyPr/>
-                    <a:lstStyle/>
-                    <a:p>
-                      <a:pPr indent="0" marL="0">
-                        <a:buNone/>
-                      </a:pPr>
-                      <a:r>
-                        <a:rPr lang="en-US" sz="1000" dirty="0">
-                          <a:solidFill>
-                            <a:srgbClr val="1F2A44"/>
-                          </a:solidFill>
-                          <a:latin typeface="Microsoft JhengHei" pitchFamily="34" charset="0"/>
-                          <a:ea typeface="Microsoft JhengHei" pitchFamily="34" charset="-122"/>
-                          <a:cs typeface="Microsoft JhengHei" pitchFamily="34" charset="-120"/>
-                        </a:rPr>
-                        <a:t>Non-domain · method</a:t>
-                      </a:r>
-                      <a:endParaRPr lang="en-US" sz="1000" dirty="0">
-                        <a:latin typeface="Microsoft JhengHei" charset="0"/>
-                        <a:ea typeface="Microsoft JhengHei" charset="0"/>
-                        <a:cs typeface="Microsoft JhengHei" charset="0"/>
-                      </a:endParaRPr>
-                    </a:p>
-                  </a:txBody>
-                  <a:tcPr marL="91440" marR="91440" marT="45720" marB="45720">
-                    <a:lnL w="6350" cap="flat" cmpd="sng" algn="ctr">
-                      <a:solidFill>
-                        <a:srgbClr val="D4DBE8"/>
-                      </a:solidFill>
-                      <a:prstDash val="solid"/>
-                      <a:round/>
-                      <a:headEnd type="none" w="med" len="med"/>
-                      <a:tailEnd type="none" w="med" len="med"/>
-                    </a:lnL>
-                    <a:lnR w="6350" cap="flat" cmpd="sng" algn="ctr">
-                      <a:solidFill>
-                        <a:srgbClr val="D4DBE8"/>
-                      </a:solidFill>
-                      <a:prstDash val="solid"/>
-                      <a:round/>
-                      <a:headEnd type="none" w="med" len="med"/>
-                      <a:tailEnd type="none" w="med" len="med"/>
-                    </a:lnR>
-                    <a:lnT w="6350" cap="flat" cmpd="sng" algn="ctr">
-                      <a:solidFill>
-                        <a:srgbClr val="D4DBE8"/>
-                      </a:solidFill>
-                      <a:prstDash val="solid"/>
-                      <a:round/>
-                      <a:headEnd type="none" w="med" len="med"/>
-                      <a:tailEnd type="none" w="med" len="med"/>
-                    </a:lnT>
-                    <a:lnB w="6350" cap="flat" cmpd="sng" algn="ctr">
-                      <a:solidFill>
-                        <a:srgbClr val="D4DBE8"/>
-                      </a:solidFill>
-                      <a:prstDash val="solid"/>
-                      <a:round/>
-                      <a:headEnd type="none" w="med" len="med"/>
-                      <a:tailEnd type="none" w="med" len="med"/>
-                    </a:lnB>
-                  </a:tcPr>
-                </a:tc>
-                <a:tc>
-                  <a:txBody>
-                    <a:bodyPr/>
-                    <a:lstStyle/>
-                    <a:p>
-                      <a:pPr algn="ctr" indent="0" marL="0">
-                        <a:buNone/>
-                      </a:pPr>
-                      <a:r>
-                        <a:rPr lang="en-US" sz="1000" b="1" dirty="0">
-                          <a:solidFill>
-                            <a:srgbClr val="1C7293"/>
-                          </a:solidFill>
-                          <a:latin typeface="Microsoft JhengHei" pitchFamily="34" charset="0"/>
-                          <a:ea typeface="Microsoft JhengHei" pitchFamily="34" charset="-122"/>
-                          <a:cs typeface="Microsoft JhengHei" pitchFamily="34" charset="-120"/>
-                        </a:rPr>
-                        <a:t>29</a:t>
-                      </a:r>
-                      <a:endParaRPr lang="en-US" sz="1000" dirty="0">
-                        <a:latin typeface="Microsoft JhengHei" charset="0"/>
-                        <a:ea typeface="Microsoft JhengHei" charset="0"/>
-                        <a:cs typeface="Microsoft JhengHei" charset="0"/>
-                      </a:endParaRPr>
-                    </a:p>
-                  </a:txBody>
-                  <a:tcPr marL="91440" marR="91440" marT="45720" marB="45720">
-                    <a:lnL w="6350" cap="flat" cmpd="sng" algn="ctr">
-                      <a:solidFill>
-                        <a:srgbClr val="D4DBE8"/>
-                      </a:solidFill>
-                      <a:prstDash val="solid"/>
-                      <a:round/>
-                      <a:headEnd type="none" w="med" len="med"/>
-                      <a:tailEnd type="none" w="med" len="med"/>
-                    </a:lnL>
-                    <a:lnR w="6350" cap="flat" cmpd="sng" algn="ctr">
-                      <a:solidFill>
-                        <a:srgbClr val="D4DBE8"/>
-                      </a:solidFill>
-                      <a:prstDash val="solid"/>
-                      <a:round/>
-                      <a:headEnd type="none" w="med" len="med"/>
-                      <a:tailEnd type="none" w="med" len="med"/>
-                    </a:lnR>
-                    <a:lnT w="6350" cap="flat" cmpd="sng" algn="ctr">
-                      <a:solidFill>
-                        <a:srgbClr val="D4DBE8"/>
-                      </a:solidFill>
-                      <a:prstDash val="solid"/>
-                      <a:round/>
-                      <a:headEnd type="none" w="med" len="med"/>
-                      <a:tailEnd type="none" w="med" len="med"/>
-                    </a:lnT>
-                    <a:lnB w="6350" cap="flat" cmpd="sng" algn="ctr">
-                      <a:solidFill>
-                        <a:srgbClr val="D4DBE8"/>
-                      </a:solidFill>
-                      <a:prstDash val="solid"/>
-                      <a:round/>
-                      <a:headEnd type="none" w="med" len="med"/>
-                      <a:tailEnd type="none" w="med" len="med"/>
-                    </a:lnB>
-                  </a:tcPr>
-                </a:tc>
-                <a:tc>
-                  <a:txBody>
-                    <a:bodyPr/>
-                    <a:lstStyle/>
-                    <a:p>
-                      <a:pPr algn="ctr" indent="0" marL="0">
-                        <a:buNone/>
-                      </a:pPr>
-                      <a:r>
-                        <a:rPr lang="en-US" sz="1000" dirty="0">
-                          <a:solidFill>
-                            <a:srgbClr val="1F2A44"/>
-                          </a:solidFill>
-                          <a:latin typeface="Microsoft JhengHei" pitchFamily="34" charset="0"/>
-                          <a:ea typeface="Microsoft JhengHei" pitchFamily="34" charset="-122"/>
-                          <a:cs typeface="Microsoft JhengHei" pitchFamily="34" charset="-120"/>
-                        </a:rPr>
-                        <a:t>0</a:t>
-                      </a:r>
-                      <a:endParaRPr lang="en-US" sz="1000" dirty="0">
-                        <a:latin typeface="Microsoft JhengHei" charset="0"/>
-                        <a:ea typeface="Microsoft JhengHei" charset="0"/>
-                        <a:cs typeface="Microsoft JhengHei" charset="0"/>
-                      </a:endParaRPr>
-                    </a:p>
-                  </a:txBody>
-                  <a:tcPr marL="91440" marR="91440" marT="45720" marB="45720">
-                    <a:lnL w="6350" cap="flat" cmpd="sng" algn="ctr">
-                      <a:solidFill>
-                        <a:srgbClr val="D4DBE8"/>
-                      </a:solidFill>
-                      <a:prstDash val="solid"/>
-                      <a:round/>
-                      <a:headEnd type="none" w="med" len="med"/>
-                      <a:tailEnd type="none" w="med" len="med"/>
-                    </a:lnL>
-                    <a:lnR w="6350" cap="flat" cmpd="sng" algn="ctr">
-                      <a:solidFill>
-                        <a:srgbClr val="D4DBE8"/>
-                      </a:solidFill>
-                      <a:prstDash val="solid"/>
-                      <a:round/>
-                      <a:headEnd type="none" w="med" len="med"/>
-                      <a:tailEnd type="none" w="med" len="med"/>
-                    </a:lnR>
-                    <a:lnT w="6350" cap="flat" cmpd="sng" algn="ctr">
-                      <a:solidFill>
-                        <a:srgbClr val="D4DBE8"/>
-                      </a:solidFill>
-                      <a:prstDash val="solid"/>
-                      <a:round/>
-                      <a:headEnd type="none" w="med" len="med"/>
-                      <a:tailEnd type="none" w="med" len="med"/>
-                    </a:lnT>
-                    <a:lnB w="6350" cap="flat" cmpd="sng" algn="ctr">
-                      <a:solidFill>
-                        <a:srgbClr val="D4DBE8"/>
-                      </a:solidFill>
-                      <a:prstDash val="solid"/>
-                      <a:round/>
-                      <a:headEnd type="none" w="med" len="med"/>
-                      <a:tailEnd type="none" w="med" len="med"/>
-                    </a:lnB>
-                  </a:tcPr>
-                </a:tc>
-                <a:tc>
-                  <a:txBody>
-                    <a:bodyPr/>
-                    <a:lstStyle/>
-                    <a:p>
-                      <a:pPr algn="ctr" indent="0" marL="0">
-                        <a:buNone/>
-                      </a:pPr>
-                      <a:r>
-                        <a:rPr lang="en-US" sz="1000" dirty="0">
-                          <a:solidFill>
-                            <a:srgbClr val="1F2A44"/>
-                          </a:solidFill>
-                          <a:latin typeface="Microsoft JhengHei" pitchFamily="34" charset="0"/>
-                          <a:ea typeface="Microsoft JhengHei" pitchFamily="34" charset="-122"/>
-                          <a:cs typeface="Microsoft JhengHei" pitchFamily="34" charset="-120"/>
-                        </a:rPr>
-                        <a:t>0</a:t>
-                      </a:r>
-                      <a:endParaRPr lang="en-US" sz="1000" dirty="0">
-                        <a:latin typeface="Microsoft JhengHei" charset="0"/>
-                        <a:ea typeface="Microsoft JhengHei" charset="0"/>
-                        <a:cs typeface="Microsoft JhengHei" charset="0"/>
-                      </a:endParaRPr>
-                    </a:p>
-                  </a:txBody>
-                  <a:tcPr marL="91440" marR="91440" marT="45720" marB="45720">
-                    <a:lnL w="6350" cap="flat" cmpd="sng" algn="ctr">
-                      <a:solidFill>
-                        <a:srgbClr val="D4DBE8"/>
-                      </a:solidFill>
-                      <a:prstDash val="solid"/>
-                      <a:round/>
-                      <a:headEnd type="none" w="med" len="med"/>
-                      <a:tailEnd type="none" w="med" len="med"/>
-                    </a:lnL>
-                    <a:lnR w="6350" cap="flat" cmpd="sng" algn="ctr">
-                      <a:solidFill>
-                        <a:srgbClr val="D4DBE8"/>
-                      </a:solidFill>
-                      <a:prstDash val="solid"/>
-                      <a:round/>
-                      <a:headEnd type="none" w="med" len="med"/>
-                      <a:tailEnd type="none" w="med" len="med"/>
-                    </a:lnR>
-                    <a:lnT w="6350" cap="flat" cmpd="sng" algn="ctr">
-                      <a:solidFill>
-                        <a:srgbClr val="D4DBE8"/>
-                      </a:solidFill>
-                      <a:prstDash val="solid"/>
-                      <a:round/>
-                      <a:headEnd type="none" w="med" len="med"/>
-                      <a:tailEnd type="none" w="med" len="med"/>
-                    </a:lnT>
-                    <a:lnB w="6350" cap="flat" cmpd="sng" algn="ctr">
-                      <a:solidFill>
-                        <a:srgbClr val="D4DBE8"/>
-                      </a:solidFill>
-                      <a:prstDash val="solid"/>
-                      <a:round/>
-                      <a:headEnd type="none" w="med" len="med"/>
-                      <a:tailEnd type="none" w="med" len="med"/>
-                    </a:lnB>
-                  </a:tcPr>
-                </a:tc>
-              </a:tr>
             </a:tbl>
           </a:graphicData>
         </a:graphic>
@@ -10283,8 +9759,8 @@
         </p:nvSpPr>
         <p:spPr>
           <a:xfrm>
-            <a:off x="8961120" y="3383280"/>
-            <a:ext cx="3108960" cy="2743200"/>
+            <a:off x="8595360" y="2743200"/>
+            <a:ext cx="3383280" cy="3383280"/>
           </a:xfrm>
           <a:prstGeom prst="rect">
             <a:avLst/>
@@ -10312,7 +9788,7 @@
                 <a:ea typeface="Microsoft JhengHei" pitchFamily="34" charset="-122"/>
                 <a:cs typeface="Microsoft JhengHei" pitchFamily="34" charset="-120"/>
               </a:rPr>
-              <a:t>Domain class set 完全不變 — 設計通過實作驗證。</a:t>
+              <a:t>12 個 Domain 類別維持不變 — 設計通過實作驗證。</a:t>
             </a:r>
             <a:endParaRPr lang="en-US" sz="1000" dirty="0"/>
           </a:p>
@@ -10333,7 +9809,7 @@
                 <a:ea typeface="Microsoft JhengHei" pitchFamily="34" charset="-122"/>
                 <a:cs typeface="Microsoft JhengHei" pitchFamily="34" charset="-120"/>
               </a:rPr>
-              <a:t>新增多為 reporter 所需之 accessor / value getter。</a:t>
+              <a:t>新增方法多為 reporter 所需之 accessor / value getter。</a:t>
             </a:r>
             <a:endParaRPr lang="en-US" sz="1000" dirty="0"/>
           </a:p>
@@ -10388,7 +9864,7 @@
                 <a:ea typeface="Microsoft JhengHei" pitchFamily="34" charset="-122"/>
                 <a:cs typeface="Microsoft JhengHei" pitchFamily="34" charset="-120"/>
               </a:rPr>
-              <a:t> 改由 ComplianceCheck 持有（單一資料來源原則）。</a:t>
+              <a:t> 改由 ComplianceCheck 持有（單一資料來源）。</a:t>
             </a:r>
             <a:endParaRPr lang="en-US" sz="1000" dirty="0"/>
           </a:p>
@@ -10410,6 +9886,27 @@
                 <a:cs typeface="Microsoft JhengHei" pitchFamily="34" charset="-120"/>
               </a:rPr>
               <a:t>0 個 method 簽章被修改。</a:t>
+            </a:r>
+            <a:endParaRPr lang="en-US" sz="1000" dirty="0"/>
+          </a:p>
+          <a:p>
+            <a:pPr marL="342900" indent="-342900">
+              <a:spcAft>
+                <a:spcPts val="400"/>
+              </a:spcAft>
+              <a:buSzPct val="100000"/>
+              <a:buChar char="•"/>
+            </a:pPr>
+            <a:r>
+              <a:rPr lang="en-US" sz="1000" i="1" dirty="0">
+                <a:solidFill>
+                  <a:srgbClr val="5B6479"/>
+                </a:solidFill>
+                <a:latin typeface="Microsoft JhengHei" pitchFamily="34" charset="0"/>
+                <a:ea typeface="Microsoft JhengHei" pitchFamily="34" charset="-122"/>
+                <a:cs typeface="Microsoft JhengHei" pitchFamily="34" charset="-120"/>
+              </a:rPr>
+              <a:t>圖聚焦 Domain Layer，便於與 HW#4 §3.3 DCD 逐類比對；Application / Infrastructure / CLI 之 port-adapter 配置詳見 §3.1 Logical Architecture。</a:t>
             </a:r>
             <a:endParaRPr lang="en-US" sz="1000" dirty="0"/>
           </a:p>
@@ -10734,7 +10231,7 @@
                 <a:ea typeface="Consolas" pitchFamily="34" charset="-122"/>
                 <a:cs typeface="Consolas" pitchFamily="34" charset="-120"/>
               </a:rPr>
-              <a:t>domain.constraint.ArchitectureConstraint</a:t>
+              <a:t>domain.rule.ComplianceRule</a:t>
             </a:r>
             <a:endParaRPr lang="en-US" sz="1000" dirty="0"/>
           </a:p>
@@ -10773,7 +10270,7 @@
                 <a:ea typeface="Consolas" pitchFamily="34" charset="-122"/>
                 <a:cs typeface="Consolas" pitchFamily="34" charset="-120"/>
               </a:rPr>
-              <a:t>public abstract class ArchitectureConstraint {</a:t>
+              <a:t>public abstract class ComplianceRule {</a:t>
             </a:r>
             <a:endParaRPr lang="en-US" sz="1000" dirty="0"/>
           </a:p>
@@ -10830,7 +10327,7 @@
                 <a:ea typeface="Consolas" pitchFamily="34" charset="-122"/>
                 <a:cs typeface="Consolas" pitchFamily="34" charset="-120"/>
               </a:rPr>
-              <a:t>    protected ArchitectureConstraint(String id, String description) {</a:t>
+              <a:t>    protected ComplianceRule(String id, String description) {</a:t>
             </a:r>
             <a:endParaRPr lang="en-US" sz="1000" dirty="0"/>
           </a:p>
@@ -11150,7 +10647,7 @@
                 <a:ea typeface="Consolas" pitchFamily="34" charset="-122"/>
                 <a:cs typeface="Consolas" pitchFamily="34" charset="-120"/>
               </a:rPr>
-              <a:t>domain.constraint.NamingRule</a:t>
+              <a:t>domain.rule.NamingRule</a:t>
             </a:r>
             <a:endParaRPr lang="en-US" sz="1000" dirty="0"/>
           </a:p>
@@ -11189,7 +10686,7 @@
                 <a:ea typeface="Consolas" pitchFamily="34" charset="-122"/>
                 <a:cs typeface="Consolas" pitchFamily="34" charset="-120"/>
               </a:rPr>
-              <a:t>public class NamingRule extends ArchitectureConstraint {</a:t>
+              <a:t>public class NamingRule extends ComplianceRule {</a:t>
             </a:r>
             <a:endParaRPr lang="en-US" sz="1000" dirty="0"/>
           </a:p>
@@ -11563,7 +11060,7 @@
                 <a:ea typeface="Microsoft JhengHei" pitchFamily="34" charset="-122"/>
                 <a:cs typeface="Microsoft JhengHei" pitchFamily="34" charset="-120"/>
               </a:rPr>
-              <a:t>Polymorphism — Service 走訪 List&lt;ArchitectureConstraint&gt; 並呼叫 validate(files)，每個子類掌管自己的演算法。</a:t>
+              <a:t>Polymorphism — Service 走訪 List&lt;ComplianceRule&gt; 並呼叫 validate(files)，每個子類掌管自己的演算法。</a:t>
             </a:r>
             <a:endParaRPr lang="en-US" sz="1000" dirty="0"/>
           </a:p>
@@ -12245,66 +11742,40 @@
           </a:p>
         </p:txBody>
       </p:sp>
-      <p:sp>
-        <p:nvSpPr>
-          <p:cNvPr id="20" name="Shape 18"/>
-          <p:cNvSpPr/>
-          <p:nvPr/>
-        </p:nvSpPr>
-        <p:spPr>
-          <a:xfrm>
-            <a:off x="502920" y="2606040"/>
-            <a:ext cx="11155680" cy="3291840"/>
-          </a:xfrm>
-          <a:prstGeom prst="rect">
-            <a:avLst/>
-          </a:prstGeom>
-          <a:solidFill>
-            <a:srgbClr val="0F1535"/>
-          </a:solidFill>
-          <a:ln w="12700">
-            <a:solidFill>
-              <a:srgbClr val="0F1535"/>
-            </a:solidFill>
-            <a:prstDash val="solid"/>
-          </a:ln>
-        </p:spPr>
-      </p:sp>
-      <p:sp>
-        <p:nvSpPr>
-          <p:cNvPr id="21" name="Shape 19"/>
-          <p:cNvSpPr/>
-          <p:nvPr/>
-        </p:nvSpPr>
-        <p:spPr>
-          <a:xfrm>
-            <a:off x="502920" y="2606040"/>
-            <a:ext cx="11155680" cy="310896"/>
-          </a:xfrm>
-          <a:prstGeom prst="rect">
-            <a:avLst/>
-          </a:prstGeom>
-          <a:solidFill>
-            <a:srgbClr val="1E2761"/>
-          </a:solidFill>
-          <a:ln w="12700">
-            <a:solidFill>
-              <a:srgbClr val="1E2761"/>
-            </a:solidFill>
-            <a:prstDash val="solid"/>
-          </a:ln>
-        </p:spPr>
-      </p:sp>
-      <p:sp>
-        <p:nvSpPr>
-          <p:cNvPr id="22" name="Text 20"/>
-          <p:cNvSpPr/>
-          <p:nvPr/>
-        </p:nvSpPr>
-        <p:spPr>
-          <a:xfrm>
-            <a:off x="4572000" y="2606040"/>
-            <a:ext cx="3017520" cy="310896"/>
+      <p:pic>
+        <p:nvPicPr>
+          <p:cNvPr id="20" name="Image 0" descr="..\hw5\images\test-result.png">    </p:cNvPr>
+          <p:cNvPicPr>
+            <a:picLocks noChangeAspect="1"/>
+          </p:cNvPicPr>
+          <p:nvPr/>
+        </p:nvPicPr>
+        <p:blipFill>
+          <a:blip r:embed="rId1"/>
+          <a:stretch>
+            <a:fillRect/>
+          </a:stretch>
+        </p:blipFill>
+        <p:spPr>
+          <a:xfrm>
+            <a:off x="2526171" y="2606040"/>
+            <a:ext cx="7139354" cy="3200400"/>
+          </a:xfrm>
+          <a:prstGeom prst="rect">
+            <a:avLst/>
+          </a:prstGeom>
+        </p:spPr>
+      </p:pic>
+      <p:sp>
+        <p:nvSpPr>
+          <p:cNvPr id="21" name="Text 18"/>
+          <p:cNvSpPr/>
+          <p:nvPr/>
+        </p:nvSpPr>
+        <p:spPr>
+          <a:xfrm>
+            <a:off x="502920" y="5897880"/>
+            <a:ext cx="11155680" cy="292608"/>
           </a:xfrm>
           <a:prstGeom prst="rect">
             <a:avLst/>
@@ -12317,305 +11788,6 @@
           <a:lstStyle/>
           <a:p>
             <a:pPr algn="ctr" indent="0" marL="0">
-              <a:buNone/>
-            </a:pPr>
-            <a:r>
-              <a:rPr lang="en-US" sz="1000" dirty="0">
-                <a:solidFill>
-                  <a:srgbClr val="CADCFC"/>
-                </a:solidFill>
-                <a:latin typeface="Microsoft JhengHei" pitchFamily="34" charset="0"/>
-                <a:ea typeface="Microsoft JhengHei" pitchFamily="34" charset="-122"/>
-                <a:cs typeface="Microsoft JhengHei" pitchFamily="34" charset="-120"/>
-              </a:rPr>
-              <a:t>mvn — JUnit 5</a:t>
-            </a:r>
-            <a:endParaRPr lang="en-US" sz="1000" dirty="0"/>
-          </a:p>
-        </p:txBody>
-      </p:sp>
-      <p:sp>
-        <p:nvSpPr>
-          <p:cNvPr id="23" name="Text 21"/>
-          <p:cNvSpPr/>
-          <p:nvPr/>
-        </p:nvSpPr>
-        <p:spPr>
-          <a:xfrm>
-            <a:off x="777240" y="2971800"/>
-            <a:ext cx="10607040" cy="2834640"/>
-          </a:xfrm>
-          <a:prstGeom prst="rect">
-            <a:avLst/>
-          </a:prstGeom>
-          <a:noFill/>
-          <a:ln/>
-        </p:spPr>
-        <p:txBody>
-          <a:bodyPr wrap="square" lIns="0" tIns="0" rIns="0" bIns="0" rtlCol="0" anchor="ctr"/>
-          <a:lstStyle/>
-          <a:p>
-            <a:pPr indent="0" marL="0">
-              <a:buNone/>
-            </a:pPr>
-            <a:r>
-              <a:rPr lang="en-US" sz="1100" dirty="0">
-                <a:solidFill>
-                  <a:srgbClr val="F4B400"/>
-                </a:solidFill>
-                <a:latin typeface="Consolas" pitchFamily="34" charset="0"/>
-                <a:ea typeface="Consolas" pitchFamily="34" charset="-122"/>
-                <a:cs typeface="Consolas" pitchFamily="34" charset="-120"/>
-              </a:rPr>
-              <a:t>$ mvn -B clean test</a:t>
-            </a:r>
-            <a:endParaRPr lang="en-US" sz="1100" dirty="0"/>
-          </a:p>
-          <a:p>
-            <a:pPr indent="0" marL="0">
-              <a:buNone/>
-            </a:pPr>
-            <a:r>
-              <a:rPr lang="en-US" sz="1100" dirty="0">
-                <a:solidFill>
-                  <a:srgbClr val="CADCFC"/>
-                </a:solidFill>
-                <a:latin typeface="Consolas" pitchFamily="34" charset="0"/>
-                <a:ea typeface="Consolas" pitchFamily="34" charset="-122"/>
-                <a:cs typeface="Consolas" pitchFamily="34" charset="-120"/>
-              </a:rPr>
-              <a:t>[INFO] -------------------------------------------------------</a:t>
-            </a:r>
-            <a:endParaRPr lang="en-US" sz="1100" dirty="0"/>
-          </a:p>
-          <a:p>
-            <a:pPr indent="0" marL="0">
-              <a:buNone/>
-            </a:pPr>
-            <a:r>
-              <a:rPr lang="en-US" sz="1100" dirty="0">
-                <a:solidFill>
-                  <a:srgbClr val="CADCFC"/>
-                </a:solidFill>
-                <a:latin typeface="Consolas" pitchFamily="34" charset="0"/>
-                <a:ea typeface="Consolas" pitchFamily="34" charset="-122"/>
-                <a:cs typeface="Consolas" pitchFamily="34" charset="-120"/>
-              </a:rPr>
-              <a:t>[INFO]  T E S T S</a:t>
-            </a:r>
-            <a:endParaRPr lang="en-US" sz="1100" dirty="0"/>
-          </a:p>
-          <a:p>
-            <a:pPr indent="0" marL="0">
-              <a:buNone/>
-            </a:pPr>
-            <a:r>
-              <a:rPr lang="en-US" sz="1100" dirty="0">
-                <a:solidFill>
-                  <a:srgbClr val="CADCFC"/>
-                </a:solidFill>
-                <a:latin typeface="Consolas" pitchFamily="34" charset="0"/>
-                <a:ea typeface="Consolas" pitchFamily="34" charset="-122"/>
-                <a:cs typeface="Consolas" pitchFamily="34" charset="-120"/>
-              </a:rPr>
-              <a:t>[INFO] -------------------------------------------------------</a:t>
-            </a:r>
-            <a:endParaRPr lang="en-US" sz="1100" dirty="0"/>
-          </a:p>
-          <a:p>
-            <a:pPr indent="0" marL="0">
-              <a:buNone/>
-            </a:pPr>
-            <a:r>
-              <a:rPr lang="en-US" sz="1100" dirty="0">
-                <a:solidFill>
-                  <a:srgbClr val="FFFFFF"/>
-                </a:solidFill>
-                <a:latin typeface="Consolas" pitchFamily="34" charset="0"/>
-                <a:ea typeface="Consolas" pitchFamily="34" charset="-122"/>
-                <a:cs typeface="Consolas" pitchFamily="34" charset="-120"/>
-              </a:rPr>
-              <a:t>[INFO] Running com.archchecker.application.ComplianceCheckServiceTest</a:t>
-            </a:r>
-            <a:endParaRPr lang="en-US" sz="1100" dirty="0"/>
-          </a:p>
-          <a:p>
-            <a:pPr indent="0" marL="0">
-              <a:buNone/>
-            </a:pPr>
-            <a:r>
-              <a:rPr lang="en-US" sz="1100" dirty="0">
-                <a:solidFill>
-                  <a:srgbClr val="FFFFFF"/>
-                </a:solidFill>
-                <a:latin typeface="Consolas" pitchFamily="34" charset="0"/>
-                <a:ea typeface="Consolas" pitchFamily="34" charset="-122"/>
-                <a:cs typeface="Consolas" pitchFamily="34" charset="-120"/>
-              </a:rPr>
-              <a:t>[INFO] Running com.archchecker.application.SuppressionServiceTest</a:t>
-            </a:r>
-            <a:endParaRPr lang="en-US" sz="1100" dirty="0"/>
-          </a:p>
-          <a:p>
-            <a:pPr indent="0" marL="0">
-              <a:buNone/>
-            </a:pPr>
-            <a:r>
-              <a:rPr lang="en-US" sz="1100" dirty="0">
-                <a:solidFill>
-                  <a:srgbClr val="FFFFFF"/>
-                </a:solidFill>
-                <a:latin typeface="Consolas" pitchFamily="34" charset="0"/>
-                <a:ea typeface="Consolas" pitchFamily="34" charset="-122"/>
-                <a:cs typeface="Consolas" pitchFamily="34" charset="-120"/>
-              </a:rPr>
-              <a:t>[INFO] Running com.archchecker.domain.constraint.NamingRuleTest</a:t>
-            </a:r>
-            <a:endParaRPr lang="en-US" sz="1100" dirty="0"/>
-          </a:p>
-          <a:p>
-            <a:pPr indent="0" marL="0">
-              <a:buNone/>
-            </a:pPr>
-            <a:r>
-              <a:rPr lang="en-US" sz="1100" dirty="0">
-                <a:solidFill>
-                  <a:srgbClr val="FFFFFF"/>
-                </a:solidFill>
-                <a:latin typeface="Consolas" pitchFamily="34" charset="0"/>
-                <a:ea typeface="Consolas" pitchFamily="34" charset="-122"/>
-                <a:cs typeface="Consolas" pitchFamily="34" charset="-120"/>
-              </a:rPr>
-              <a:t>[INFO] Running com.archchecker.domain.constraint.DependencyRuleTest</a:t>
-            </a:r>
-            <a:endParaRPr lang="en-US" sz="1100" dirty="0"/>
-          </a:p>
-          <a:p>
-            <a:pPr indent="0" marL="0">
-              <a:buNone/>
-            </a:pPr>
-            <a:r>
-              <a:rPr lang="en-US" sz="1100" dirty="0">
-                <a:solidFill>
-                  <a:srgbClr val="FFFFFF"/>
-                </a:solidFill>
-                <a:latin typeface="Consolas" pitchFamily="34" charset="0"/>
-                <a:ea typeface="Consolas" pitchFamily="34" charset="-122"/>
-                <a:cs typeface="Consolas" pitchFamily="34" charset="-120"/>
-              </a:rPr>
-              <a:t>[INFO] Running com.archchecker.domain.constraint.SupertypeRuleTest</a:t>
-            </a:r>
-            <a:endParaRPr lang="en-US" sz="1100" dirty="0"/>
-          </a:p>
-          <a:p>
-            <a:pPr indent="0" marL="0">
-              <a:buNone/>
-            </a:pPr>
-            <a:r>
-              <a:rPr lang="en-US" sz="1100" dirty="0">
-                <a:solidFill>
-                  <a:srgbClr val="FFFFFF"/>
-                </a:solidFill>
-                <a:latin typeface="Consolas" pitchFamily="34" charset="0"/>
-                <a:ea typeface="Consolas" pitchFamily="34" charset="-122"/>
-                <a:cs typeface="Consolas" pitchFamily="34" charset="-120"/>
-              </a:rPr>
-              <a:t>[INFO] Running com.archchecker.domain.constraint.PackageRuleTest</a:t>
-            </a:r>
-            <a:endParaRPr lang="en-US" sz="1100" dirty="0"/>
-          </a:p>
-          <a:p>
-            <a:pPr indent="0" marL="0">
-              <a:buNone/>
-            </a:pPr>
-            <a:r>
-              <a:rPr lang="en-US" sz="1100" dirty="0">
-                <a:solidFill>
-                  <a:srgbClr val="FFFFFF"/>
-                </a:solidFill>
-                <a:latin typeface="Consolas" pitchFamily="34" charset="0"/>
-                <a:ea typeface="Consolas" pitchFamily="34" charset="-122"/>
-                <a:cs typeface="Consolas" pitchFamily="34" charset="-120"/>
-              </a:rPr>
-              <a:t>[INFO] Running com.archchecker.infrastructure.profile.YamlProfileRepositoryTest</a:t>
-            </a:r>
-            <a:endParaRPr lang="en-US" sz="1100" dirty="0"/>
-          </a:p>
-          <a:p>
-            <a:pPr indent="0" marL="0">
-              <a:buNone/>
-            </a:pPr>
-            <a:r>
-              <a:rPr lang="en-US" sz="1100" dirty="0">
-                <a:solidFill>
-                  <a:srgbClr val="FFFFFF"/>
-                </a:solidFill>
-                <a:latin typeface="Consolas" pitchFamily="34" charset="0"/>
-                <a:ea typeface="Consolas" pitchFamily="34" charset="-122"/>
-                <a:cs typeface="Consolas" pitchFamily="34" charset="-120"/>
-              </a:rPr>
-              <a:t>[INFO] Running com.archchecker.infrastructure.suppression.YamlSuppressionRepositoryTest</a:t>
-            </a:r>
-            <a:endParaRPr lang="en-US" sz="1100" dirty="0"/>
-          </a:p>
-          <a:p>
-            <a:pPr indent="0" marL="0">
-              <a:buNone/>
-            </a:pPr>
-            <a:r>
-              <a:rPr lang="en-US" sz="1100" b="1" dirty="0">
-                <a:solidFill>
-                  <a:srgbClr val="70C77B"/>
-                </a:solidFill>
-                <a:latin typeface="Consolas" pitchFamily="34" charset="0"/>
-                <a:ea typeface="Consolas" pitchFamily="34" charset="-122"/>
-                <a:cs typeface="Consolas" pitchFamily="34" charset="-120"/>
-              </a:rPr>
-              <a:t>[INFO] Tests run: 21, Failures: 0, Errors: 0, Skipped: 0</a:t>
-            </a:r>
-            <a:endParaRPr lang="en-US" sz="1100" dirty="0"/>
-          </a:p>
-          <a:p>
-            <a:pPr indent="0" marL="0">
-              <a:buNone/>
-            </a:pPr>
-            <a:r>
-              <a:rPr lang="en-US" sz="1100" b="1" dirty="0">
-                <a:solidFill>
-                  <a:srgbClr val="70C77B"/>
-                </a:solidFill>
-                <a:latin typeface="Consolas" pitchFamily="34" charset="0"/>
-                <a:ea typeface="Consolas" pitchFamily="34" charset="-122"/>
-                <a:cs typeface="Consolas" pitchFamily="34" charset="-120"/>
-              </a:rPr>
-              <a:t>[INFO] BUILD SUCCESS</a:t>
-            </a:r>
-            <a:endParaRPr lang="en-US" sz="1100" dirty="0"/>
-          </a:p>
-        </p:txBody>
-      </p:sp>
-      <p:sp>
-        <p:nvSpPr>
-          <p:cNvPr id="24" name="Text 22"/>
-          <p:cNvSpPr/>
-          <p:nvPr/>
-        </p:nvSpPr>
-        <p:spPr>
-          <a:xfrm>
-            <a:off x="502920" y="5989320"/>
-            <a:ext cx="11155680" cy="292608"/>
-          </a:xfrm>
-          <a:prstGeom prst="rect">
-            <a:avLst/>
-          </a:prstGeom>
-          <a:noFill/>
-          <a:ln/>
-        </p:spPr>
-        <p:txBody>
-          <a:bodyPr wrap="square" lIns="0" tIns="0" rIns="0" bIns="0" rtlCol="0" anchor="ctr"/>
-          <a:lstStyle/>
-          <a:p>
-            <a:pPr indent="0" marL="0">
               <a:buNone/>
             </a:pPr>
             <a:r>
@@ -12952,7 +12124,7 @@
                 <a:ea typeface="Consolas" pitchFamily="34" charset="-122"/>
                 <a:cs typeface="Consolas" pitchFamily="34" charset="-120"/>
               </a:rPr>
-              <a:t>src/test/java/com/archchecker/domain/constraint/NamingRuleTest.java</a:t>
+              <a:t>src/test/java/com/archchecker/domain/rule/NamingRuleTest.java</a:t>
             </a:r>
             <a:endParaRPr lang="en-US" sz="1000" dirty="0"/>
           </a:p>
@@ -13219,7 +12391,7 @@
                 <a:ea typeface="Consolas" pitchFamily="34" charset="-122"/>
                 <a:cs typeface="Consolas" pitchFamily="34" charset="-120"/>
               </a:rPr>
-              <a:t>        assertThat(v.getConstraint().getId()).isEqualTo("NR-1");</a:t>
+              <a:t>        assertThat(v.getRule().getId()).isEqualTo("NR-1");</a:t>
             </a:r>
             <a:endParaRPr lang="en-US" sz="1100" dirty="0"/>
           </a:p>
@@ -19755,7 +18927,7 @@
                 <a:ea typeface="Microsoft JhengHei" pitchFamily="34" charset="-122"/>
                 <a:cs typeface="Microsoft JhengHei" pitchFamily="34" charset="-120"/>
               </a:rPr>
-              <a:t>對每個檔案套用 Profile 中所有 ArchitectureConstraint</a:t>
+              <a:t>對每個檔案套用 Profile 中所有 ComplianceRule</a:t>
             </a:r>
             <a:endParaRPr lang="en-US" sz="1100" dirty="0"/>
           </a:p>
@@ -21100,7 +20272,7 @@
                 <a:ea typeface="Microsoft JhengHei" pitchFamily="34" charset="-122"/>
                 <a:cs typeface="Microsoft JhengHei" pitchFamily="34" charset="-120"/>
               </a:rPr>
-              <a:t>Developer 發出 suppress(constraintId, filePath, lineNumber, reason)</a:t>
+              <a:t>Developer 發出 suppress(ruleId, filePath, lineNumber, reason)</a:t>
             </a:r>
             <a:endParaRPr lang="en-US" sz="1200" dirty="0"/>
           </a:p>
@@ -21166,7 +20338,7 @@
                 <a:ea typeface="Microsoft JhengHei" pitchFamily="34" charset="-122"/>
                 <a:cs typeface="Microsoft JhengHei" pitchFamily="34" charset="-120"/>
               </a:rPr>
-              <a:t>SuppressionRepository 將其持久化至 .arch-checker-suppressions.yaml</a:t>
+              <a:t>SuppressionStore 將其持久化至 .arch-checker-suppressions.yaml</a:t>
             </a:r>
             <a:endParaRPr lang="en-US" sz="1200" dirty="0"/>
           </a:p>
@@ -21420,7 +20592,7 @@
                 <a:ea typeface="Microsoft JhengHei" pitchFamily="34" charset="-122"/>
                 <a:cs typeface="Microsoft JhengHei" pitchFamily="34" charset="-120"/>
               </a:rPr>
-              <a:t>2a · constraintId 為空 → exit 2 (validation error)</a:t>
+              <a:t>2a · ruleId 為空 → exit 2 (validation error)</a:t>
             </a:r>
             <a:endParaRPr lang="en-US" sz="1200" dirty="0"/>
           </a:p>
@@ -21483,7 +20655,7 @@
                 <a:ea typeface="Microsoft JhengHei" pitchFamily="34" charset="-122"/>
                 <a:cs typeface="Microsoft JhengHei" pitchFamily="34" charset="-120"/>
               </a:rPr>
-              <a:t>4a · Repository 寫入失敗 → exit 2（避免遺孤 Suppression）</a:t>
+              <a:t>4a · SuppressionStore 寫入失敗 → exit 2（避免遺孤 Suppression）</a:t>
             </a:r>
             <a:endParaRPr lang="en-US" sz="1200" dirty="0"/>
           </a:p>
@@ -21607,7 +20779,7 @@
                 <a:ea typeface="Microsoft JhengHei" pitchFamily="34" charset="-122"/>
                 <a:cs typeface="Microsoft JhengHei" pitchFamily="34" charset="-120"/>
               </a:rPr>
-              <a:t>Indirection / Protected Variation · Repository 隱藏 YAML I/O</a:t>
+              <a:t>Indirection / Protected Variation · SuppressionStore 隱藏 YAML I/O</a:t>
             </a:r>
             <a:endParaRPr lang="en-US" sz="1100" dirty="0"/>
           </a:p>
@@ -22727,7 +21899,7 @@
                 <a:ea typeface="Microsoft JhengHei" pitchFamily="34" charset="-122"/>
                 <a:cs typeface="Microsoft JhengHei" pitchFamily="34" charset="-120"/>
               </a:rPr>
-              <a:t>Demo Snapshot · UC-01 成功流程</a:t>
+              <a:t>Demo Snapshot · UC-01 Check Architecture Compliance</a:t>
             </a:r>
             <a:endParaRPr lang="en-US" sz="2400" dirty="0"/>
           </a:p>
@@ -22834,141 +22006,40 @@
           </a:p>
         </p:txBody>
       </p:sp>
-      <p:sp>
-        <p:nvSpPr>
-          <p:cNvPr id="9" name="Shape 7"/>
-          <p:cNvSpPr/>
-          <p:nvPr/>
-        </p:nvSpPr>
-        <p:spPr>
-          <a:xfrm>
-            <a:off x="502920" y="1051560"/>
-            <a:ext cx="11155680" cy="4846320"/>
-          </a:xfrm>
-          <a:prstGeom prst="rect">
-            <a:avLst/>
-          </a:prstGeom>
-          <a:solidFill>
-            <a:srgbClr val="0F1535"/>
-          </a:solidFill>
-          <a:ln w="12700">
-            <a:solidFill>
-              <a:srgbClr val="0F1535"/>
-            </a:solidFill>
-            <a:prstDash val="solid"/>
-          </a:ln>
-        </p:spPr>
-      </p:sp>
-      <p:sp>
-        <p:nvSpPr>
-          <p:cNvPr id="10" name="Shape 8"/>
-          <p:cNvSpPr/>
-          <p:nvPr/>
-        </p:nvSpPr>
-        <p:spPr>
-          <a:xfrm>
-            <a:off x="502920" y="1051560"/>
-            <a:ext cx="11155680" cy="329184"/>
-          </a:xfrm>
-          <a:prstGeom prst="rect">
-            <a:avLst/>
-          </a:prstGeom>
-          <a:solidFill>
-            <a:srgbClr val="1E2761"/>
-          </a:solidFill>
-          <a:ln w="12700">
-            <a:solidFill>
-              <a:srgbClr val="1E2761"/>
-            </a:solidFill>
-            <a:prstDash val="solid"/>
-          </a:ln>
-        </p:spPr>
-      </p:sp>
-      <p:sp>
-        <p:nvSpPr>
-          <p:cNvPr id="11" name="Shape 9"/>
-          <p:cNvSpPr/>
-          <p:nvPr/>
-        </p:nvSpPr>
-        <p:spPr>
-          <a:xfrm>
-            <a:off x="640080" y="1124712"/>
-            <a:ext cx="182880" cy="182880"/>
-          </a:xfrm>
-          <a:prstGeom prst="ellipse">
-            <a:avLst/>
-          </a:prstGeom>
-          <a:solidFill>
-            <a:srgbClr val="F96167"/>
-          </a:solidFill>
-          <a:ln w="12700">
-            <a:solidFill>
-              <a:srgbClr val="F96167"/>
-            </a:solidFill>
-            <a:prstDash val="solid"/>
-          </a:ln>
-        </p:spPr>
-      </p:sp>
-      <p:sp>
-        <p:nvSpPr>
-          <p:cNvPr id="12" name="Shape 10"/>
-          <p:cNvSpPr/>
-          <p:nvPr/>
-        </p:nvSpPr>
-        <p:spPr>
-          <a:xfrm>
-            <a:off x="868680" y="1124712"/>
-            <a:ext cx="182880" cy="182880"/>
-          </a:xfrm>
-          <a:prstGeom prst="ellipse">
-            <a:avLst/>
-          </a:prstGeom>
-          <a:solidFill>
-            <a:srgbClr val="F4B400"/>
-          </a:solidFill>
-          <a:ln w="12700">
-            <a:solidFill>
-              <a:srgbClr val="F4B400"/>
-            </a:solidFill>
-            <a:prstDash val="solid"/>
-          </a:ln>
-        </p:spPr>
-      </p:sp>
-      <p:sp>
-        <p:nvSpPr>
-          <p:cNvPr id="13" name="Shape 11"/>
-          <p:cNvSpPr/>
-          <p:nvPr/>
-        </p:nvSpPr>
-        <p:spPr>
-          <a:xfrm>
-            <a:off x="1097280" y="1124712"/>
-            <a:ext cx="182880" cy="182880"/>
-          </a:xfrm>
-          <a:prstGeom prst="ellipse">
-            <a:avLst/>
-          </a:prstGeom>
-          <a:solidFill>
-            <a:srgbClr val="70C77B"/>
-          </a:solidFill>
-          <a:ln w="12700">
-            <a:solidFill>
-              <a:srgbClr val="70C77B"/>
-            </a:solidFill>
-            <a:prstDash val="solid"/>
-          </a:ln>
-        </p:spPr>
-      </p:sp>
-      <p:sp>
-        <p:nvSpPr>
-          <p:cNvPr id="14" name="Text 12"/>
-          <p:cNvSpPr/>
-          <p:nvPr/>
-        </p:nvSpPr>
-        <p:spPr>
-          <a:xfrm>
-            <a:off x="4572000" y="1051560"/>
-            <a:ext cx="3017520" cy="329184"/>
+      <p:pic>
+        <p:nvPicPr>
+          <p:cNvPr id="9" name="Image 0" descr="..\hw5\images\arch-checker-build-success.png">    </p:cNvPr>
+          <p:cNvPicPr>
+            <a:picLocks noChangeAspect="1"/>
+          </p:cNvPicPr>
+          <p:nvPr/>
+        </p:nvPicPr>
+        <p:blipFill>
+          <a:blip r:embed="rId1"/>
+          <a:stretch>
+            <a:fillRect/>
+          </a:stretch>
+        </p:blipFill>
+        <p:spPr>
+          <a:xfrm>
+            <a:off x="5006979" y="960120"/>
+            <a:ext cx="2177736" cy="2194560"/>
+          </a:xfrm>
+          <a:prstGeom prst="rect">
+            <a:avLst/>
+          </a:prstGeom>
+        </p:spPr>
+      </p:pic>
+      <p:sp>
+        <p:nvSpPr>
+          <p:cNvPr id="10" name="Text 7"/>
+          <p:cNvSpPr/>
+          <p:nvPr/>
+        </p:nvSpPr>
+        <p:spPr>
+          <a:xfrm>
+            <a:off x="502920" y="3200400"/>
+            <a:ext cx="11155680" cy="274320"/>
           </a:xfrm>
           <a:prstGeom prst="rect">
             <a:avLst/>
@@ -22984,30 +22055,54 @@
               <a:buNone/>
             </a:pPr>
             <a:r>
-              <a:rPr lang="en-US" sz="1000" dirty="0">
-                <a:solidFill>
-                  <a:srgbClr val="CADCFC"/>
-                </a:solidFill>
-                <a:latin typeface="Microsoft JhengHei" pitchFamily="34" charset="0"/>
-                <a:ea typeface="Microsoft JhengHei" pitchFamily="34" charset="-122"/>
-                <a:cs typeface="Microsoft JhengHei" pitchFamily="34" charset="-120"/>
-              </a:rPr>
-              <a:t>zsh — arch-checker</a:t>
-            </a:r>
-            <a:endParaRPr lang="en-US" sz="1000" dirty="0"/>
+              <a:rPr lang="en-US" sz="1100" i="1" dirty="0">
+                <a:solidFill>
+                  <a:srgbClr val="1C7293"/>
+                </a:solidFill>
+                <a:latin typeface="Microsoft JhengHei" pitchFamily="34" charset="0"/>
+                <a:ea typeface="Microsoft JhengHei" pitchFamily="34" charset="-122"/>
+                <a:cs typeface="Microsoft JhengHei" pitchFamily="34" charset="-120"/>
+              </a:rPr>
+              <a:t>① mvn package — BUILD SUCCESS</a:t>
+            </a:r>
+            <a:endParaRPr lang="en-US" sz="1100" dirty="0"/>
           </a:p>
         </p:txBody>
       </p:sp>
-      <p:sp>
-        <p:nvSpPr>
-          <p:cNvPr id="15" name="Text 13"/>
-          <p:cNvSpPr/>
-          <p:nvPr/>
-        </p:nvSpPr>
-        <p:spPr>
-          <a:xfrm>
-            <a:off x="777240" y="1554480"/>
-            <a:ext cx="10607040" cy="4114800"/>
+      <p:pic>
+        <p:nvPicPr>
+          <p:cNvPr id="11" name="Image 1" descr="..\hw5\images\sample-project-check.png">    </p:cNvPr>
+          <p:cNvPicPr>
+            <a:picLocks noChangeAspect="1"/>
+          </p:cNvPicPr>
+          <p:nvPr/>
+        </p:nvPicPr>
+        <p:blipFill>
+          <a:blip r:embed="rId2"/>
+          <a:stretch>
+            <a:fillRect/>
+          </a:stretch>
+        </p:blipFill>
+        <p:spPr>
+          <a:xfrm>
+            <a:off x="518008" y="3566160"/>
+            <a:ext cx="11155680" cy="1134074"/>
+          </a:xfrm>
+          <a:prstGeom prst="rect">
+            <a:avLst/>
+          </a:prstGeom>
+        </p:spPr>
+      </p:pic>
+      <p:sp>
+        <p:nvSpPr>
+          <p:cNvPr id="12" name="Text 8"/>
+          <p:cNvSpPr/>
+          <p:nvPr/>
+        </p:nvSpPr>
+        <p:spPr>
+          <a:xfrm>
+            <a:off x="502920" y="4745954"/>
+            <a:ext cx="11155680" cy="274320"/>
           </a:xfrm>
           <a:prstGeom prst="rect">
             <a:avLst/>
@@ -23019,165 +22114,34 @@
           <a:bodyPr wrap="square" lIns="0" tIns="0" rIns="0" bIns="0" rtlCol="0" anchor="ctr"/>
           <a:lstStyle/>
           <a:p>
-            <a:pPr indent="0" marL="0">
-              <a:buNone/>
-            </a:pPr>
-            <a:r>
-              <a:rPr lang="en-US" sz="1400" dirty="0">
-                <a:solidFill>
-                  <a:srgbClr val="F4B400"/>
-                </a:solidFill>
-                <a:latin typeface="Consolas" pitchFamily="34" charset="0"/>
-                <a:ea typeface="Consolas" pitchFamily="34" charset="-122"/>
-                <a:cs typeface="Consolas" pitchFamily="34" charset="-120"/>
-              </a:rPr>
-              <a:t>$ mvn -B package -DskipTests dependency:copy-dependencies \</a:t>
-            </a:r>
-            <a:endParaRPr lang="en-US" sz="1400" dirty="0"/>
-          </a:p>
-          <a:p>
-            <a:pPr indent="0" marL="0">
-              <a:buNone/>
-            </a:pPr>
-            <a:r>
-              <a:rPr lang="en-US" sz="1400" dirty="0">
-                <a:solidFill>
-                  <a:srgbClr val="F4B400"/>
-                </a:solidFill>
-                <a:latin typeface="Consolas" pitchFamily="34" charset="0"/>
-                <a:ea typeface="Consolas" pitchFamily="34" charset="-122"/>
-                <a:cs typeface="Consolas" pitchFamily="34" charset="-120"/>
-              </a:rPr>
-              <a:t>      -DincludeScope=runtime -DoutputDirectory=target/lib</a:t>
-            </a:r>
-            <a:endParaRPr lang="en-US" sz="1400" dirty="0"/>
-          </a:p>
-          <a:p>
-            <a:pPr indent="0" marL="0">
-              <a:buNone/>
-            </a:pPr>
-            <a:r>
-              <a:rPr lang="en-US" sz="1400" dirty="0">
-                <a:solidFill>
-                  <a:srgbClr val="70C77B"/>
-                </a:solidFill>
-                <a:latin typeface="Consolas" pitchFamily="34" charset="0"/>
-                <a:ea typeface="Consolas" pitchFamily="34" charset="-122"/>
-                <a:cs typeface="Consolas" pitchFamily="34" charset="-120"/>
-              </a:rPr>
-              <a:t>[INFO] BUILD SUCCESS</a:t>
-            </a:r>
-            <a:endParaRPr lang="en-US" sz="1400" dirty="0"/>
-          </a:p>
-          <a:p>
-            <a:pPr indent="0" marL="0">
-              <a:buNone/>
-            </a:pPr>
-            <a:endParaRPr lang="en-US" sz="1400" dirty="0"/>
-          </a:p>
-          <a:p>
-            <a:pPr indent="0" marL="0">
-              <a:buNone/>
-            </a:pPr>
-            <a:r>
-              <a:rPr lang="en-US" sz="1400" dirty="0">
-                <a:solidFill>
-                  <a:srgbClr val="F4B400"/>
-                </a:solidFill>
-                <a:latin typeface="Consolas" pitchFamily="34" charset="0"/>
-                <a:ea typeface="Consolas" pitchFamily="34" charset="-122"/>
-                <a:cs typeface="Consolas" pitchFamily="34" charset="-120"/>
-              </a:rPr>
-              <a:t>$ java -cp 'target/arch-checker.jar;target/lib/*' \</a:t>
-            </a:r>
-            <a:endParaRPr lang="en-US" sz="1400" dirty="0"/>
-          </a:p>
-          <a:p>
-            <a:pPr indent="0" marL="0">
-              <a:buNone/>
-            </a:pPr>
-            <a:r>
-              <a:rPr lang="en-US" sz="1400" dirty="0">
-                <a:solidFill>
-                  <a:srgbClr val="F4B400"/>
-                </a:solidFill>
-                <a:latin typeface="Consolas" pitchFamily="34" charset="0"/>
-                <a:ea typeface="Consolas" pitchFamily="34" charset="-122"/>
-                <a:cs typeface="Consolas" pitchFamily="34" charset="-120"/>
-              </a:rPr>
-              <a:t>      com.archchecker.cli.Main check src/main/java arch.yaml</a:t>
-            </a:r>
-            <a:endParaRPr lang="en-US" sz="1400" dirty="0"/>
-          </a:p>
-          <a:p>
-            <a:pPr indent="0" marL="0">
-              <a:buNone/>
-            </a:pPr>
-            <a:r>
-              <a:rPr lang="en-US" sz="1400" dirty="0">
-                <a:solidFill>
-                  <a:srgbClr val="FFFFFF"/>
-                </a:solidFill>
-                <a:latin typeface="Consolas" pitchFamily="34" charset="0"/>
-                <a:ea typeface="Consolas" pitchFamily="34" charset="-122"/>
-                <a:cs typeface="Consolas" pitchFamily="34" charset="-120"/>
-              </a:rPr>
-              <a:t>-- Checked 26 file(s); 0 violation(s); 0 suppressed.</a:t>
-            </a:r>
-            <a:endParaRPr lang="en-US" sz="1400" dirty="0"/>
-          </a:p>
-          <a:p>
-            <a:pPr indent="0" marL="0">
-              <a:buNone/>
-            </a:pPr>
-            <a:endParaRPr lang="en-US" sz="1400" dirty="0"/>
-          </a:p>
-          <a:p>
-            <a:pPr indent="0" marL="0">
-              <a:buNone/>
-            </a:pPr>
-            <a:r>
-              <a:rPr lang="en-US" sz="1400" dirty="0">
-                <a:solidFill>
-                  <a:srgbClr val="F4B400"/>
-                </a:solidFill>
-                <a:latin typeface="Consolas" pitchFamily="34" charset="0"/>
-                <a:ea typeface="Consolas" pitchFamily="34" charset="-122"/>
-                <a:cs typeface="Consolas" pitchFamily="34" charset="-120"/>
-              </a:rPr>
-              <a:t>$ echo $?</a:t>
-            </a:r>
-            <a:endParaRPr lang="en-US" sz="1400" dirty="0"/>
-          </a:p>
-          <a:p>
-            <a:pPr indent="0" marL="0">
-              <a:buNone/>
-            </a:pPr>
-            <a:r>
-              <a:rPr lang="en-US" sz="1400" b="1" dirty="0">
-                <a:solidFill>
-                  <a:srgbClr val="70C77B"/>
-                </a:solidFill>
-                <a:latin typeface="Consolas" pitchFamily="34" charset="0"/>
-                <a:ea typeface="Consolas" pitchFamily="34" charset="-122"/>
-                <a:cs typeface="Consolas" pitchFamily="34" charset="-120"/>
-              </a:rPr>
-              <a:t>0</a:t>
-            </a:r>
-            <a:endParaRPr lang="en-US" sz="1400" dirty="0"/>
+            <a:pPr algn="ctr" indent="0" marL="0">
+              <a:buNone/>
+            </a:pPr>
+            <a:r>
+              <a:rPr lang="en-US" sz="1100" i="1" dirty="0">
+                <a:solidFill>
+                  <a:srgbClr val="1C7293"/>
+                </a:solidFill>
+                <a:latin typeface="Microsoft JhengHei" pitchFamily="34" charset="0"/>
+                <a:ea typeface="Microsoft JhengHei" pitchFamily="34" charset="-122"/>
+                <a:cs typeface="Microsoft JhengHei" pitchFamily="34" charset="-120"/>
+              </a:rPr>
+              <a:t>② arch-checker check demo/sample-project — 偵測 4 筆違規（exit 1）</a:t>
+            </a:r>
+            <a:endParaRPr lang="en-US" sz="1100" dirty="0"/>
           </a:p>
         </p:txBody>
       </p:sp>
       <p:sp>
         <p:nvSpPr>
-          <p:cNvPr id="16" name="Text 14"/>
-          <p:cNvSpPr/>
-          <p:nvPr/>
-        </p:nvSpPr>
-        <p:spPr>
-          <a:xfrm>
-            <a:off x="502920" y="5943600"/>
-            <a:ext cx="11155680" cy="502920"/>
+          <p:cNvPr id="13" name="Text 9"/>
+          <p:cNvSpPr/>
+          <p:nvPr/>
+        </p:nvSpPr>
+        <p:spPr>
+          <a:xfrm>
+            <a:off x="502920" y="6080760"/>
+            <a:ext cx="11155680" cy="365760"/>
           </a:xfrm>
           <a:prstGeom prst="rect">
             <a:avLst/>
@@ -23189,7 +22153,7 @@
           <a:bodyPr wrap="square" lIns="0" tIns="0" rIns="0" bIns="0" rtlCol="0" anchor="ctr"/>
           <a:lstStyle/>
           <a:p>
-            <a:pPr indent="0" marL="0">
+            <a:pPr algn="ctr" indent="0" marL="0">
               <a:buNone/>
             </a:pPr>
             <a:r>
@@ -23201,24 +22165,7 @@
                 <a:ea typeface="Microsoft JhengHei" pitchFamily="34" charset="-122"/>
                 <a:cs typeface="Microsoft JhengHei" pitchFamily="34" charset="-120"/>
               </a:rPr>
-              <a:t>arch-checker 將自身 26 個 class 對 arch.yaml 檢查 — 0 violations，exit 0。</a:t>
-            </a:r>
-            <a:endParaRPr lang="en-US" sz="1000" dirty="0"/>
-          </a:p>
-          <a:p>
-            <a:pPr indent="0" marL="0">
-              <a:buNone/>
-            </a:pPr>
-            <a:r>
-              <a:rPr lang="en-US" sz="1000" i="1" dirty="0">
-                <a:solidFill>
-                  <a:srgbClr val="5B6479"/>
-                </a:solidFill>
-                <a:latin typeface="Microsoft JhengHei" pitchFamily="34" charset="0"/>
-                <a:ea typeface="Microsoft JhengHei" pitchFamily="34" charset="-122"/>
-                <a:cs typeface="Microsoft JhengHei" pitchFamily="34" charset="-120"/>
-              </a:rPr>
-              <a:t>對應 UC-01 主流程（步驟 1-10）以及 NFR-05（POSIX exit code）。</a:t>
+              <a:t>對應 UC-01 主流程：載入 Profile（UC-05）→ 解析 .java AST → 依序套用 4 條 ComplianceRule → 報告違規與 exit code。</a:t>
             </a:r>
             <a:endParaRPr lang="en-US" sz="1000" dirty="0"/>
           </a:p>
@@ -23378,7 +22325,7 @@
                 <a:ea typeface="Microsoft JhengHei" pitchFamily="34" charset="-122"/>
                 <a:cs typeface="Microsoft JhengHei" pitchFamily="34" charset="-120"/>
               </a:rPr>
-              <a:t>Demo Snapshot · UC-04 Suppress + 重檢 (UC-01)</a:t>
+              <a:t>Demo Snapshot · UC-04 Suppress + 重檢</a:t>
             </a:r>
             <a:endParaRPr lang="en-US" sz="2400" dirty="0"/>
           </a:p>
@@ -23485,180 +22432,40 @@
           </a:p>
         </p:txBody>
       </p:sp>
-      <p:sp>
-        <p:nvSpPr>
-          <p:cNvPr id="9" name="Shape 7"/>
-          <p:cNvSpPr/>
-          <p:nvPr/>
-        </p:nvSpPr>
-        <p:spPr>
-          <a:xfrm>
-            <a:off x="502920" y="1051560"/>
-            <a:ext cx="11155680" cy="4846320"/>
-          </a:xfrm>
-          <a:prstGeom prst="rect">
-            <a:avLst/>
-          </a:prstGeom>
-          <a:solidFill>
-            <a:srgbClr val="0F1535"/>
-          </a:solidFill>
-          <a:ln w="12700">
-            <a:solidFill>
-              <a:srgbClr val="0F1535"/>
-            </a:solidFill>
-            <a:prstDash val="solid"/>
-          </a:ln>
-        </p:spPr>
-      </p:sp>
-      <p:sp>
-        <p:nvSpPr>
-          <p:cNvPr id="10" name="Shape 8"/>
-          <p:cNvSpPr/>
-          <p:nvPr/>
-        </p:nvSpPr>
-        <p:spPr>
-          <a:xfrm>
-            <a:off x="502920" y="1051560"/>
-            <a:ext cx="11155680" cy="329184"/>
-          </a:xfrm>
-          <a:prstGeom prst="rect">
-            <a:avLst/>
-          </a:prstGeom>
-          <a:solidFill>
-            <a:srgbClr val="1E2761"/>
-          </a:solidFill>
-          <a:ln w="12700">
-            <a:solidFill>
-              <a:srgbClr val="1E2761"/>
-            </a:solidFill>
-            <a:prstDash val="solid"/>
-          </a:ln>
-        </p:spPr>
-      </p:sp>
-      <p:sp>
-        <p:nvSpPr>
-          <p:cNvPr id="11" name="Shape 9"/>
-          <p:cNvSpPr/>
-          <p:nvPr/>
-        </p:nvSpPr>
-        <p:spPr>
-          <a:xfrm>
-            <a:off x="640080" y="1124712"/>
-            <a:ext cx="182880" cy="182880"/>
-          </a:xfrm>
-          <a:prstGeom prst="ellipse">
-            <a:avLst/>
-          </a:prstGeom>
-          <a:solidFill>
-            <a:srgbClr val="F96167"/>
-          </a:solidFill>
-          <a:ln w="12700">
-            <a:solidFill>
-              <a:srgbClr val="F96167"/>
-            </a:solidFill>
-            <a:prstDash val="solid"/>
-          </a:ln>
-        </p:spPr>
-      </p:sp>
-      <p:sp>
-        <p:nvSpPr>
-          <p:cNvPr id="12" name="Shape 10"/>
-          <p:cNvSpPr/>
-          <p:nvPr/>
-        </p:nvSpPr>
-        <p:spPr>
-          <a:xfrm>
-            <a:off x="868680" y="1124712"/>
-            <a:ext cx="182880" cy="182880"/>
-          </a:xfrm>
-          <a:prstGeom prst="ellipse">
-            <a:avLst/>
-          </a:prstGeom>
-          <a:solidFill>
-            <a:srgbClr val="F4B400"/>
-          </a:solidFill>
-          <a:ln w="12700">
-            <a:solidFill>
-              <a:srgbClr val="F4B400"/>
-            </a:solidFill>
-            <a:prstDash val="solid"/>
-          </a:ln>
-        </p:spPr>
-      </p:sp>
-      <p:sp>
-        <p:nvSpPr>
-          <p:cNvPr id="13" name="Shape 11"/>
-          <p:cNvSpPr/>
-          <p:nvPr/>
-        </p:nvSpPr>
-        <p:spPr>
-          <a:xfrm>
-            <a:off x="1097280" y="1124712"/>
-            <a:ext cx="182880" cy="182880"/>
-          </a:xfrm>
-          <a:prstGeom prst="ellipse">
-            <a:avLst/>
-          </a:prstGeom>
-          <a:solidFill>
-            <a:srgbClr val="70C77B"/>
-          </a:solidFill>
-          <a:ln w="12700">
-            <a:solidFill>
-              <a:srgbClr val="70C77B"/>
-            </a:solidFill>
-            <a:prstDash val="solid"/>
-          </a:ln>
-        </p:spPr>
-      </p:sp>
-      <p:sp>
-        <p:nvSpPr>
-          <p:cNvPr id="14" name="Text 12"/>
-          <p:cNvSpPr/>
-          <p:nvPr/>
-        </p:nvSpPr>
-        <p:spPr>
-          <a:xfrm>
-            <a:off x="4572000" y="1051560"/>
-            <a:ext cx="3017520" cy="329184"/>
-          </a:xfrm>
-          <a:prstGeom prst="rect">
-            <a:avLst/>
-          </a:prstGeom>
-          <a:noFill/>
-          <a:ln/>
-        </p:spPr>
-        <p:txBody>
-          <a:bodyPr wrap="square" lIns="0" tIns="0" rIns="0" bIns="0" rtlCol="0" anchor="ctr"/>
-          <a:lstStyle/>
-          <a:p>
-            <a:pPr algn="ctr" indent="0" marL="0">
-              <a:buNone/>
-            </a:pPr>
-            <a:r>
-              <a:rPr lang="en-US" sz="1000" dirty="0">
-                <a:solidFill>
-                  <a:srgbClr val="CADCFC"/>
-                </a:solidFill>
-                <a:latin typeface="Microsoft JhengHei" pitchFamily="34" charset="0"/>
-                <a:ea typeface="Microsoft JhengHei" pitchFamily="34" charset="-122"/>
-                <a:cs typeface="Microsoft JhengHei" pitchFamily="34" charset="-120"/>
-              </a:rPr>
-              <a:t>zsh — arch-checker</a:t>
-            </a:r>
-            <a:endParaRPr lang="en-US" sz="1000" dirty="0"/>
-          </a:p>
-        </p:txBody>
-      </p:sp>
-      <p:sp>
-        <p:nvSpPr>
-          <p:cNvPr id="15" name="Text 13"/>
-          <p:cNvSpPr/>
-          <p:nvPr/>
-        </p:nvSpPr>
-        <p:spPr>
-          <a:xfrm>
-            <a:off x="777240" y="1481328"/>
-            <a:ext cx="10607040" cy="4297680"/>
+      <p:pic>
+        <p:nvPicPr>
+          <p:cNvPr id="9" name="Image 0" descr="..\hw5\images\suppress-demo.png">    </p:cNvPr>
+          <p:cNvPicPr>
+            <a:picLocks noChangeAspect="1"/>
+          </p:cNvPicPr>
+          <p:nvPr/>
+        </p:nvPicPr>
+        <p:blipFill>
+          <a:blip r:embed="rId1"/>
+          <a:stretch>
+            <a:fillRect/>
+          </a:stretch>
+        </p:blipFill>
+        <p:spPr>
+          <a:xfrm>
+            <a:off x="518008" y="1051560"/>
+            <a:ext cx="11155680" cy="2270162"/>
+          </a:xfrm>
+          <a:prstGeom prst="rect">
+            <a:avLst/>
+          </a:prstGeom>
+        </p:spPr>
+      </p:pic>
+      <p:sp>
+        <p:nvSpPr>
+          <p:cNvPr id="10" name="Text 7"/>
+          <p:cNvSpPr/>
+          <p:nvPr/>
+        </p:nvSpPr>
+        <p:spPr>
+          <a:xfrm>
+            <a:off x="502920" y="3550322"/>
+            <a:ext cx="11155680" cy="914400"/>
           </a:xfrm>
           <a:prstGeom prst="rect">
             <a:avLst/>
@@ -23677,19 +22484,16 @@
               <a:buNone/>
             </a:pPr>
             <a:r>
-              <a:rPr lang="en-US" sz="1100" dirty="0">
-                <a:solidFill>
-                  <a:srgbClr val="CADCFC"/>
-                </a:solidFill>
-                <a:latin typeface="Consolas" pitchFamily="34" charset="0"/>
-                <a:ea typeface="Consolas" pitchFamily="34" charset="-122"/>
-                <a:cs typeface="Consolas" pitchFamily="34" charset="-120"/>
-              </a:rPr>
-              <a:t># 1. 第一次檢查 — 出現一筆 NamingRule 違規</a:t>
-            </a:r>
-            <a:endParaRPr lang="en-US" sz="1100" dirty="0"/>
-          </a:p>
-          <a:p>
+              <a:rPr lang="en-US" sz="1100" b="1" dirty="0">
+                <a:solidFill>
+                  <a:srgbClr val="1E2761"/>
+                </a:solidFill>
+                <a:latin typeface="Microsoft JhengHei" pitchFamily="34" charset="0"/>
+                <a:ea typeface="Microsoft JhengHei" pitchFamily="34" charset="-122"/>
+                <a:cs typeface="Microsoft JhengHei" pitchFamily="34" charset="-120"/>
+              </a:rPr>
+              <a:t>① </a:t>
+            </a:r>
             <a:pPr indent="0" marL="0">
               <a:spcAft>
                 <a:spcPts val="200"/>
@@ -23699,13 +22503,13 @@
             <a:r>
               <a:rPr lang="en-US" sz="1100" dirty="0">
                 <a:solidFill>
-                  <a:srgbClr val="F4B400"/>
-                </a:solidFill>
-                <a:latin typeface="Consolas" pitchFamily="34" charset="0"/>
-                <a:ea typeface="Consolas" pitchFamily="34" charset="-122"/>
-                <a:cs typeface="Consolas" pitchFamily="34" charset="-120"/>
-              </a:rPr>
-              <a:t>$ java …Main check sample-project demo.yaml</a:t>
+                  <a:srgbClr val="1F2A44"/>
+                </a:solidFill>
+                <a:latin typeface="Microsoft JhengHei" pitchFamily="34" charset="0"/>
+                <a:ea typeface="Microsoft JhengHei" pitchFamily="34" charset="-122"/>
+                <a:cs typeface="Microsoft JhengHei" pitchFamily="34" charset="-120"/>
+              </a:rPr>
+              <a:t>suppress R-NAME-01 @ PaymentManager.java:12（reason: legacy name）→ 寫入 .arch-checker-suppress.yaml</a:t>
             </a:r>
             <a:endParaRPr lang="en-US" sz="1100" dirty="0"/>
           </a:p>
@@ -23717,19 +22521,16 @@
               <a:buNone/>
             </a:pPr>
             <a:r>
-              <a:rPr lang="en-US" sz="1100" dirty="0">
-                <a:solidFill>
-                  <a:srgbClr val="F96167"/>
-                </a:solidFill>
-                <a:latin typeface="Consolas" pitchFamily="34" charset="0"/>
-                <a:ea typeface="Consolas" pitchFamily="34" charset="-122"/>
-                <a:cs typeface="Consolas" pitchFamily="34" charset="-120"/>
-              </a:rPr>
-              <a:t>[VIOLATION] NamingRule  src/.../UserManager.java:7  Class must end with 'Service'</a:t>
-            </a:r>
-            <a:endParaRPr lang="en-US" sz="1100" dirty="0"/>
-          </a:p>
-          <a:p>
+              <a:rPr lang="en-US" sz="1100" b="1" dirty="0">
+                <a:solidFill>
+                  <a:srgbClr val="1E2761"/>
+                </a:solidFill>
+                <a:latin typeface="Microsoft JhengHei" pitchFamily="34" charset="0"/>
+                <a:ea typeface="Microsoft JhengHei" pitchFamily="34" charset="-122"/>
+                <a:cs typeface="Microsoft JhengHei" pitchFamily="34" charset="-120"/>
+              </a:rPr>
+              <a:t>② </a:t>
+            </a:r>
             <a:pPr indent="0" marL="0">
               <a:spcAft>
                 <a:spcPts val="200"/>
@@ -23739,186 +22540,28 @@
             <a:r>
               <a:rPr lang="en-US" sz="1100" dirty="0">
                 <a:solidFill>
-                  <a:srgbClr val="FFFFFF"/>
-                </a:solidFill>
-                <a:latin typeface="Consolas" pitchFamily="34" charset="0"/>
-                <a:ea typeface="Consolas" pitchFamily="34" charset="-122"/>
-                <a:cs typeface="Consolas" pitchFamily="34" charset="-120"/>
-              </a:rPr>
-              <a:t>-- Checked 3 file(s); 1 violation(s); 0 suppressed.   exit 1</a:t>
+                  <a:srgbClr val="1F2A44"/>
+                </a:solidFill>
+                <a:latin typeface="Microsoft JhengHei" pitchFamily="34" charset="0"/>
+                <a:ea typeface="Microsoft JhengHei" pitchFamily="34" charset="-122"/>
+                <a:cs typeface="Microsoft JhengHei" pitchFamily="34" charset="-120"/>
+              </a:rPr>
+              <a:t>重新 check：違規由 4 筆降為 3 筆，1 筆計入 suppressed（exit 仍為 1，因仍有未豁免之違規）</a:t>
             </a:r>
             <a:endParaRPr lang="en-US" sz="1100" dirty="0"/>
           </a:p>
-          <a:p>
-            <a:pPr indent="0" marL="0">
-              <a:spcAft>
-                <a:spcPts val="200"/>
-              </a:spcAft>
-              <a:buNone/>
-            </a:pPr>
-            <a:endParaRPr lang="en-US" sz="1100" dirty="0"/>
-          </a:p>
-          <a:p>
-            <a:pPr indent="0" marL="0">
-              <a:spcAft>
-                <a:spcPts val="200"/>
-              </a:spcAft>
-              <a:buNone/>
-            </a:pPr>
-            <a:r>
-              <a:rPr lang="en-US" sz="1100" dirty="0">
-                <a:solidFill>
-                  <a:srgbClr val="CADCFC"/>
-                </a:solidFill>
-                <a:latin typeface="Consolas" pitchFamily="34" charset="0"/>
-                <a:ea typeface="Consolas" pitchFamily="34" charset="-122"/>
-                <a:cs typeface="Consolas" pitchFamily="34" charset="-120"/>
-              </a:rPr>
-              <a:t># 2. 將該已知個案 suppress 起來 (UC-04)</a:t>
-            </a:r>
-            <a:endParaRPr lang="en-US" sz="1100" dirty="0"/>
-          </a:p>
-          <a:p>
-            <a:pPr indent="0" marL="0">
-              <a:spcAft>
-                <a:spcPts val="200"/>
-              </a:spcAft>
-              <a:buNone/>
-            </a:pPr>
-            <a:r>
-              <a:rPr lang="en-US" sz="1100" dirty="0">
-                <a:solidFill>
-                  <a:srgbClr val="F4B400"/>
-                </a:solidFill>
-                <a:latin typeface="Consolas" pitchFamily="34" charset="0"/>
-                <a:ea typeface="Consolas" pitchFamily="34" charset="-122"/>
-                <a:cs typeface="Consolas" pitchFamily="34" charset="-120"/>
-              </a:rPr>
-              <a:t>$ java …Main suppress NamingRule .../UserManager.java 7 \</a:t>
-            </a:r>
-            <a:endParaRPr lang="en-US" sz="1100" dirty="0"/>
-          </a:p>
-          <a:p>
-            <a:pPr indent="0" marL="0">
-              <a:spcAft>
-                <a:spcPts val="200"/>
-              </a:spcAft>
-              <a:buNone/>
-            </a:pPr>
-            <a:r>
-              <a:rPr lang="en-US" sz="1100" dirty="0">
-                <a:solidFill>
-                  <a:srgbClr val="F4B400"/>
-                </a:solidFill>
-                <a:latin typeface="Consolas" pitchFamily="34" charset="0"/>
-                <a:ea typeface="Consolas" pitchFamily="34" charset="-122"/>
-                <a:cs typeface="Consolas" pitchFamily="34" charset="-120"/>
-              </a:rPr>
-              <a:t>         --reason '舊有進入點，預計 v2 重新命名'</a:t>
-            </a:r>
-            <a:endParaRPr lang="en-US" sz="1100" dirty="0"/>
-          </a:p>
-          <a:p>
-            <a:pPr indent="0" marL="0">
-              <a:spcAft>
-                <a:spcPts val="200"/>
-              </a:spcAft>
-              <a:buNone/>
-            </a:pPr>
-            <a:r>
-              <a:rPr lang="en-US" sz="1100" dirty="0">
-                <a:solidFill>
-                  <a:srgbClr val="70C77B"/>
-                </a:solidFill>
-                <a:latin typeface="Consolas" pitchFamily="34" charset="0"/>
-                <a:ea typeface="Consolas" pitchFamily="34" charset="-122"/>
-                <a:cs typeface="Consolas" pitchFamily="34" charset="-120"/>
-              </a:rPr>
-              <a:t>Suppression saved · id=NamingRule@UserManager.java:7  ts=2026-04-29T10:42Z</a:t>
-            </a:r>
-            <a:endParaRPr lang="en-US" sz="1100" dirty="0"/>
-          </a:p>
-          <a:p>
-            <a:pPr indent="0" marL="0">
-              <a:spcAft>
-                <a:spcPts val="200"/>
-              </a:spcAft>
-              <a:buNone/>
-            </a:pPr>
-            <a:endParaRPr lang="en-US" sz="1100" dirty="0"/>
-          </a:p>
-          <a:p>
-            <a:pPr indent="0" marL="0">
-              <a:spcAft>
-                <a:spcPts val="200"/>
-              </a:spcAft>
-              <a:buNone/>
-            </a:pPr>
-            <a:r>
-              <a:rPr lang="en-US" sz="1100" dirty="0">
-                <a:solidFill>
-                  <a:srgbClr val="CADCFC"/>
-                </a:solidFill>
-                <a:latin typeface="Consolas" pitchFamily="34" charset="0"/>
-                <a:ea typeface="Consolas" pitchFamily="34" charset="-122"/>
-                <a:cs typeface="Consolas" pitchFamily="34" charset="-120"/>
-              </a:rPr>
-              <a:t># 3. 重新執行 UC-01 — 違規被過濾</a:t>
-            </a:r>
-            <a:endParaRPr lang="en-US" sz="1100" dirty="0"/>
-          </a:p>
-          <a:p>
-            <a:pPr indent="0" marL="0">
-              <a:spcAft>
-                <a:spcPts val="200"/>
-              </a:spcAft>
-              <a:buNone/>
-            </a:pPr>
-            <a:r>
-              <a:rPr lang="en-US" sz="1100" dirty="0">
-                <a:solidFill>
-                  <a:srgbClr val="F4B400"/>
-                </a:solidFill>
-                <a:latin typeface="Consolas" pitchFamily="34" charset="0"/>
-                <a:ea typeface="Consolas" pitchFamily="34" charset="-122"/>
-                <a:cs typeface="Consolas" pitchFamily="34" charset="-120"/>
-              </a:rPr>
-              <a:t>$ java …Main check sample-project demo.yaml</a:t>
-            </a:r>
-            <a:endParaRPr lang="en-US" sz="1100" dirty="0"/>
-          </a:p>
-          <a:p>
-            <a:pPr indent="0" marL="0">
-              <a:spcAft>
-                <a:spcPts val="200"/>
-              </a:spcAft>
-              <a:buNone/>
-            </a:pPr>
-            <a:r>
-              <a:rPr lang="en-US" sz="1100" b="1" dirty="0">
-                <a:solidFill>
-                  <a:srgbClr val="70C77B"/>
-                </a:solidFill>
-                <a:latin typeface="Consolas" pitchFamily="34" charset="0"/>
-                <a:ea typeface="Consolas" pitchFamily="34" charset="-122"/>
-                <a:cs typeface="Consolas" pitchFamily="34" charset="-120"/>
-              </a:rPr>
-              <a:t>-- Checked 3 file(s); 0 violation(s); 1 suppressed.   exit 0</a:t>
-            </a:r>
-            <a:endParaRPr lang="en-US" sz="1100" dirty="0"/>
-          </a:p>
         </p:txBody>
       </p:sp>
       <p:sp>
         <p:nvSpPr>
-          <p:cNvPr id="16" name="Text 14"/>
-          <p:cNvSpPr/>
-          <p:nvPr/>
-        </p:nvSpPr>
-        <p:spPr>
-          <a:xfrm>
-            <a:off x="502920" y="5943600"/>
-            <a:ext cx="11155680" cy="411480"/>
+          <p:cNvPr id="11" name="Text 8"/>
+          <p:cNvSpPr/>
+          <p:nvPr/>
+        </p:nvSpPr>
+        <p:spPr>
+          <a:xfrm>
+            <a:off x="502920" y="6080760"/>
+            <a:ext cx="11155680" cy="365760"/>
           </a:xfrm>
           <a:prstGeom prst="rect">
             <a:avLst/>
@@ -23930,7 +22573,7 @@
           <a:bodyPr wrap="square" lIns="0" tIns="0" rIns="0" bIns="0" rtlCol="0" anchor="ctr"/>
           <a:lstStyle/>
           <a:p>
-            <a:pPr indent="0" marL="0">
+            <a:pPr algn="ctr" indent="0" marL="0">
               <a:buNone/>
             </a:pPr>
             <a:r>
@@ -23942,7 +22585,7 @@
                 <a:ea typeface="Microsoft JhengHei" pitchFamily="34" charset="-122"/>
                 <a:cs typeface="Microsoft JhengHei" pitchFamily="34" charset="-120"/>
               </a:rPr>
-              <a:t>對應 UC-04 主流程 + UC-01 步驟 8（過濾已 suppress 之違規）。展示 GRASP Indirection：Repository 獨佔 YAML I/O。</a:t>
+              <a:t>對應 UC-04 主流程 + UC-01 步驟 8（過濾已 suppress 之違規）。GRASP Indirection / Protected Variations · SuppressionStore 獨佔 YAML I/O。</a:t>
             </a:r>
             <a:endParaRPr lang="en-US" sz="1000" dirty="0"/>
           </a:p>
@@ -24102,7 +22745,7 @@
                 <a:ea typeface="Microsoft JhengHei" pitchFamily="34" charset="-122"/>
                 <a:cs typeface="Microsoft JhengHei" pitchFamily="34" charset="-120"/>
               </a:rPr>
-              <a:t>Demo Snapshot · 替代輸出 (FEA-04)</a:t>
+              <a:t>Demo Snapshot · 替代輸出 (FEA-04 JSON)</a:t>
             </a:r>
             <a:endParaRPr lang="en-US" sz="2400" dirty="0"/>
           </a:p>
@@ -24209,141 +22852,40 @@
           </a:p>
         </p:txBody>
       </p:sp>
-      <p:sp>
-        <p:nvSpPr>
-          <p:cNvPr id="9" name="Shape 7"/>
-          <p:cNvSpPr/>
-          <p:nvPr/>
-        </p:nvSpPr>
-        <p:spPr>
-          <a:xfrm>
-            <a:off x="502920" y="1051560"/>
-            <a:ext cx="11155680" cy="4846320"/>
-          </a:xfrm>
-          <a:prstGeom prst="rect">
-            <a:avLst/>
-          </a:prstGeom>
-          <a:solidFill>
-            <a:srgbClr val="0F1535"/>
-          </a:solidFill>
-          <a:ln w="12700">
-            <a:solidFill>
-              <a:srgbClr val="0F1535"/>
-            </a:solidFill>
-            <a:prstDash val="solid"/>
-          </a:ln>
-        </p:spPr>
-      </p:sp>
-      <p:sp>
-        <p:nvSpPr>
-          <p:cNvPr id="10" name="Shape 8"/>
-          <p:cNvSpPr/>
-          <p:nvPr/>
-        </p:nvSpPr>
-        <p:spPr>
-          <a:xfrm>
-            <a:off x="502920" y="1051560"/>
-            <a:ext cx="11155680" cy="329184"/>
-          </a:xfrm>
-          <a:prstGeom prst="rect">
-            <a:avLst/>
-          </a:prstGeom>
-          <a:solidFill>
-            <a:srgbClr val="1E2761"/>
-          </a:solidFill>
-          <a:ln w="12700">
-            <a:solidFill>
-              <a:srgbClr val="1E2761"/>
-            </a:solidFill>
-            <a:prstDash val="solid"/>
-          </a:ln>
-        </p:spPr>
-      </p:sp>
-      <p:sp>
-        <p:nvSpPr>
-          <p:cNvPr id="11" name="Shape 9"/>
-          <p:cNvSpPr/>
-          <p:nvPr/>
-        </p:nvSpPr>
-        <p:spPr>
-          <a:xfrm>
-            <a:off x="640080" y="1124712"/>
-            <a:ext cx="182880" cy="182880"/>
-          </a:xfrm>
-          <a:prstGeom prst="ellipse">
-            <a:avLst/>
-          </a:prstGeom>
-          <a:solidFill>
-            <a:srgbClr val="F96167"/>
-          </a:solidFill>
-          <a:ln w="12700">
-            <a:solidFill>
-              <a:srgbClr val="F96167"/>
-            </a:solidFill>
-            <a:prstDash val="solid"/>
-          </a:ln>
-        </p:spPr>
-      </p:sp>
-      <p:sp>
-        <p:nvSpPr>
-          <p:cNvPr id="12" name="Shape 10"/>
-          <p:cNvSpPr/>
-          <p:nvPr/>
-        </p:nvSpPr>
-        <p:spPr>
-          <a:xfrm>
-            <a:off x="868680" y="1124712"/>
-            <a:ext cx="182880" cy="182880"/>
-          </a:xfrm>
-          <a:prstGeom prst="ellipse">
-            <a:avLst/>
-          </a:prstGeom>
-          <a:solidFill>
-            <a:srgbClr val="F4B400"/>
-          </a:solidFill>
-          <a:ln w="12700">
-            <a:solidFill>
-              <a:srgbClr val="F4B400"/>
-            </a:solidFill>
-            <a:prstDash val="solid"/>
-          </a:ln>
-        </p:spPr>
-      </p:sp>
-      <p:sp>
-        <p:nvSpPr>
-          <p:cNvPr id="13" name="Shape 11"/>
-          <p:cNvSpPr/>
-          <p:nvPr/>
-        </p:nvSpPr>
-        <p:spPr>
-          <a:xfrm>
-            <a:off x="1097280" y="1124712"/>
-            <a:ext cx="182880" cy="182880"/>
-          </a:xfrm>
-          <a:prstGeom prst="ellipse">
-            <a:avLst/>
-          </a:prstGeom>
-          <a:solidFill>
-            <a:srgbClr val="70C77B"/>
-          </a:solidFill>
-          <a:ln w="12700">
-            <a:solidFill>
-              <a:srgbClr val="70C77B"/>
-            </a:solidFill>
-            <a:prstDash val="solid"/>
-          </a:ln>
-        </p:spPr>
-      </p:sp>
-      <p:sp>
-        <p:nvSpPr>
-          <p:cNvPr id="14" name="Text 12"/>
-          <p:cNvSpPr/>
-          <p:nvPr/>
-        </p:nvSpPr>
-        <p:spPr>
-          <a:xfrm>
-            <a:off x="4572000" y="1051560"/>
-            <a:ext cx="3017520" cy="329184"/>
+      <p:pic>
+        <p:nvPicPr>
+          <p:cNvPr id="9" name="Image 0" descr="..\hw5\images\json-output-demo.png">    </p:cNvPr>
+          <p:cNvPicPr>
+            <a:picLocks noChangeAspect="1"/>
+          </p:cNvPicPr>
+          <p:nvPr/>
+        </p:nvPicPr>
+        <p:blipFill>
+          <a:blip r:embed="rId1"/>
+          <a:stretch>
+            <a:fillRect/>
+          </a:stretch>
+        </p:blipFill>
+        <p:spPr>
+          <a:xfrm>
+            <a:off x="2855573" y="1005840"/>
+            <a:ext cx="6480549" cy="4572000"/>
+          </a:xfrm>
+          <a:prstGeom prst="rect">
+            <a:avLst/>
+          </a:prstGeom>
+        </p:spPr>
+      </p:pic>
+      <p:sp>
+        <p:nvSpPr>
+          <p:cNvPr id="10" name="Text 7"/>
+          <p:cNvSpPr/>
+          <p:nvPr/>
+        </p:nvSpPr>
+        <p:spPr>
+          <a:xfrm>
+            <a:off x="502920" y="5715000"/>
+            <a:ext cx="11155680" cy="822960"/>
           </a:xfrm>
           <a:prstGeom prst="rect">
             <a:avLst/>
@@ -24355,34 +22897,233 @@
           <a:bodyPr wrap="square" lIns="0" tIns="0" rIns="0" bIns="0" rtlCol="0" anchor="ctr"/>
           <a:lstStyle/>
           <a:p>
-            <a:pPr algn="ctr" indent="0" marL="0">
+            <a:pPr indent="0" marL="0">
+              <a:buNone/>
+            </a:pPr>
+            <a:r>
+              <a:rPr lang="en-US" sz="1000" b="1" dirty="0">
+                <a:solidFill>
+                  <a:srgbClr val="1E2761"/>
+                </a:solidFill>
+                <a:latin typeface="Microsoft JhengHei" pitchFamily="34" charset="0"/>
+                <a:ea typeface="Microsoft JhengHei" pitchFamily="34" charset="-122"/>
+                <a:cs typeface="Microsoft JhengHei" pitchFamily="34" charset="-120"/>
+              </a:rPr>
+              <a:t>① </a:t>
+            </a:r>
+            <a:pPr indent="0" marL="0">
               <a:buNone/>
             </a:pPr>
             <a:r>
               <a:rPr lang="en-US" sz="1000" dirty="0">
                 <a:solidFill>
-                  <a:srgbClr val="CADCFC"/>
-                </a:solidFill>
-                <a:latin typeface="Microsoft JhengHei" pitchFamily="34" charset="0"/>
-                <a:ea typeface="Microsoft JhengHei" pitchFamily="34" charset="-122"/>
-                <a:cs typeface="Microsoft JhengHei" pitchFamily="34" charset="-120"/>
-              </a:rPr>
-              <a:t>zsh — arch-checker</a:t>
+                  <a:srgbClr val="1E2761"/>
+                </a:solidFill>
+                <a:latin typeface="Consolas" pitchFamily="34" charset="0"/>
+                <a:ea typeface="Consolas" pitchFamily="34" charset="-122"/>
+                <a:cs typeface="Consolas" pitchFamily="34" charset="-120"/>
+              </a:rPr>
+              <a:t>--json</a:t>
+            </a:r>
+            <a:pPr indent="0" marL="0">
+              <a:buNone/>
+            </a:pPr>
+            <a:r>
+              <a:rPr lang="en-US" sz="1000" dirty="0">
+                <a:solidFill>
+                  <a:srgbClr val="1F2A44"/>
+                </a:solidFill>
+                <a:latin typeface="Microsoft JhengHei" pitchFamily="34" charset="0"/>
+                <a:ea typeface="Microsoft JhengHei" pitchFamily="34" charset="-122"/>
+                <a:cs typeface="Microsoft JhengHei" pitchFamily="34" charset="-120"/>
+              </a:rPr>
+              <a:t> flag 切換 </a:t>
+            </a:r>
+            <a:pPr indent="0" marL="0">
+              <a:buNone/>
+            </a:pPr>
+            <a:r>
+              <a:rPr lang="en-US" sz="1000" dirty="0">
+                <a:solidFill>
+                  <a:srgbClr val="1E2761"/>
+                </a:solidFill>
+                <a:latin typeface="Consolas" pitchFamily="34" charset="0"/>
+                <a:ea typeface="Consolas" pitchFamily="34" charset="-122"/>
+                <a:cs typeface="Consolas" pitchFamily="34" charset="-120"/>
+              </a:rPr>
+              <a:t>JsonReporter</a:t>
+            </a:r>
+            <a:pPr indent="0" marL="0">
+              <a:buNone/>
+            </a:pPr>
+            <a:r>
+              <a:rPr lang="en-US" sz="1000" dirty="0">
+                <a:solidFill>
+                  <a:srgbClr val="1F2A44"/>
+                </a:solidFill>
+                <a:latin typeface="Microsoft JhengHei" pitchFamily="34" charset="0"/>
+                <a:ea typeface="Microsoft JhengHei" pitchFamily="34" charset="-122"/>
+                <a:cs typeface="Microsoft JhengHei" pitchFamily="34" charset="-120"/>
+              </a:rPr>
+              <a:t>（Strategy）；以 </a:t>
+            </a:r>
+            <a:pPr indent="0" marL="0">
+              <a:buNone/>
+            </a:pPr>
+            <a:r>
+              <a:rPr lang="en-US" sz="1000" dirty="0">
+                <a:solidFill>
+                  <a:srgbClr val="1E2761"/>
+                </a:solidFill>
+                <a:latin typeface="Consolas" pitchFamily="34" charset="0"/>
+                <a:ea typeface="Consolas" pitchFamily="34" charset="-122"/>
+                <a:cs typeface="Consolas" pitchFamily="34" charset="-120"/>
+              </a:rPr>
+              <a:t>PowerShell </a:t>
+            </a:r>
+            <a:pPr indent="0" marL="0">
+              <a:buNone/>
+            </a:pPr>
+            <a:r>
+              <a:rPr lang="en-US" sz="1000" b="1" dirty="0">
+                <a:solidFill>
+                  <a:srgbClr val="F4B400"/>
+                </a:solidFill>
+                <a:latin typeface="Consolas" pitchFamily="34" charset="0"/>
+                <a:ea typeface="Consolas" pitchFamily="34" charset="-122"/>
+                <a:cs typeface="Consolas" pitchFamily="34" charset="-120"/>
+              </a:rPr>
+              <a:t>&gt;</a:t>
+            </a:r>
+            <a:pPr indent="0" marL="0">
+              <a:buNone/>
+            </a:pPr>
+            <a:r>
+              <a:rPr lang="en-US" sz="1000" dirty="0">
+                <a:solidFill>
+                  <a:srgbClr val="1F2A44"/>
+                </a:solidFill>
+                <a:latin typeface="Microsoft JhengHei" pitchFamily="34" charset="0"/>
+                <a:ea typeface="Microsoft JhengHei" pitchFamily="34" charset="-122"/>
+                <a:cs typeface="Microsoft JhengHei" pitchFamily="34" charset="-120"/>
+              </a:rPr>
+              <a:t> 重導向落地為 </a:t>
+            </a:r>
+            <a:pPr indent="0" marL="0">
+              <a:buNone/>
+            </a:pPr>
+            <a:r>
+              <a:rPr lang="en-US" sz="1000" dirty="0">
+                <a:solidFill>
+                  <a:srgbClr val="1E2761"/>
+                </a:solidFill>
+                <a:latin typeface="Consolas" pitchFamily="34" charset="0"/>
+                <a:ea typeface="Consolas" pitchFamily="34" charset="-122"/>
+                <a:cs typeface="Consolas" pitchFamily="34" charset="-120"/>
+              </a:rPr>
+              <a:t>.json</a:t>
+            </a:r>
+            <a:pPr indent="0" marL="0">
+              <a:buNone/>
+            </a:pPr>
+            <a:r>
+              <a:rPr lang="en-US" sz="1000" dirty="0">
+                <a:solidFill>
+                  <a:srgbClr val="1F2A44"/>
+                </a:solidFill>
+                <a:latin typeface="Microsoft JhengHei" pitchFamily="34" charset="0"/>
+                <a:ea typeface="Microsoft JhengHei" pitchFamily="34" charset="-122"/>
+                <a:cs typeface="Microsoft JhengHei" pitchFamily="34" charset="-120"/>
+              </a:rPr>
+              <a:t> 檔。</a:t>
             </a:r>
             <a:endParaRPr lang="en-US" sz="1000" dirty="0"/>
           </a:p>
+          <a:p>
+            <a:pPr indent="0" marL="0">
+              <a:buNone/>
+            </a:pPr>
+            <a:r>
+              <a:rPr lang="en-US" sz="1000" b="1" dirty="0">
+                <a:solidFill>
+                  <a:srgbClr val="1E2761"/>
+                </a:solidFill>
+                <a:latin typeface="Microsoft JhengHei" pitchFamily="34" charset="0"/>
+                <a:ea typeface="Microsoft JhengHei" pitchFamily="34" charset="-122"/>
+                <a:cs typeface="Microsoft JhengHei" pitchFamily="34" charset="-120"/>
+              </a:rPr>
+              <a:t>② </a:t>
+            </a:r>
+            <a:pPr indent="0" marL="0">
+              <a:buNone/>
+            </a:pPr>
+            <a:r>
+              <a:rPr lang="en-US" sz="1000" dirty="0">
+                <a:solidFill>
+                  <a:srgbClr val="1E2761"/>
+                </a:solidFill>
+                <a:latin typeface="Consolas" pitchFamily="34" charset="0"/>
+                <a:ea typeface="Consolas" pitchFamily="34" charset="-122"/>
+                <a:cs typeface="Consolas" pitchFamily="34" charset="-120"/>
+              </a:rPr>
+              <a:t>ConvertFrom-Json | ConvertTo-Json</a:t>
+            </a:r>
+            <a:pPr indent="0" marL="0">
+              <a:buNone/>
+            </a:pPr>
+            <a:r>
+              <a:rPr lang="en-US" sz="1000" dirty="0">
+                <a:solidFill>
+                  <a:srgbClr val="1F2A44"/>
+                </a:solidFill>
+                <a:latin typeface="Microsoft JhengHei" pitchFamily="34" charset="0"/>
+                <a:ea typeface="Microsoft JhengHei" pitchFamily="34" charset="-122"/>
+                <a:cs typeface="Microsoft JhengHei" pitchFamily="34" charset="-120"/>
+              </a:rPr>
+              <a:t> 美化呈現結構：</a:t>
+            </a:r>
+            <a:pPr indent="0" marL="0">
+              <a:buNone/>
+            </a:pPr>
+            <a:r>
+              <a:rPr lang="en-US" sz="1000" dirty="0">
+                <a:solidFill>
+                  <a:srgbClr val="1C7293"/>
+                </a:solidFill>
+                <a:latin typeface="Consolas" pitchFamily="34" charset="0"/>
+                <a:ea typeface="Consolas" pitchFamily="34" charset="-122"/>
+                <a:cs typeface="Consolas" pitchFamily="34" charset="-120"/>
+              </a:rPr>
+              <a:t>checkedFiles / violationCount / suppressedCount / violations[]</a:t>
+            </a:r>
+            <a:pPr indent="0" marL="0">
+              <a:buNone/>
+            </a:pPr>
+            <a:r>
+              <a:rPr lang="en-US" sz="1000" dirty="0">
+                <a:solidFill>
+                  <a:srgbClr val="1F2A44"/>
+                </a:solidFill>
+                <a:latin typeface="Microsoft JhengHei" pitchFamily="34" charset="0"/>
+                <a:ea typeface="Microsoft JhengHei" pitchFamily="34" charset="-122"/>
+                <a:cs typeface="Microsoft JhengHei" pitchFamily="34" charset="-120"/>
+              </a:rPr>
+              <a:t>。</a:t>
+            </a:r>
+            <a:endParaRPr lang="en-US" sz="1000" dirty="0"/>
+          </a:p>
         </p:txBody>
       </p:sp>
       <p:sp>
         <p:nvSpPr>
-          <p:cNvPr id="15" name="Text 13"/>
-          <p:cNvSpPr/>
-          <p:nvPr/>
-        </p:nvSpPr>
-        <p:spPr>
-          <a:xfrm>
-            <a:off x="777240" y="1481328"/>
-            <a:ext cx="10607040" cy="4297680"/>
+          <p:cNvPr id="11" name="Text 8"/>
+          <p:cNvSpPr/>
+          <p:nvPr/>
+        </p:nvSpPr>
+        <p:spPr>
+          <a:xfrm>
+            <a:off x="502920" y="6080760"/>
+            <a:ext cx="11155680" cy="365760"/>
           </a:xfrm>
           <a:prstGeom prst="rect">
             <a:avLst/>
@@ -24394,278 +23135,7 @@
           <a:bodyPr wrap="square" lIns="0" tIns="0" rIns="0" bIns="0" rtlCol="0" anchor="ctr"/>
           <a:lstStyle/>
           <a:p>
-            <a:pPr indent="0" marL="0">
-              <a:spcAft>
-                <a:spcPts val="200"/>
-              </a:spcAft>
-              <a:buNone/>
-            </a:pPr>
-            <a:r>
-              <a:rPr lang="en-US" sz="1200" dirty="0">
-                <a:solidFill>
-                  <a:srgbClr val="CADCFC"/>
-                </a:solidFill>
-                <a:latin typeface="Consolas" pitchFamily="34" charset="0"/>
-                <a:ea typeface="Consolas" pitchFamily="34" charset="-122"/>
-                <a:cs typeface="Consolas" pitchFamily="34" charset="-120"/>
-              </a:rPr>
-              <a:t># 給 CI dashboard 使用的 JSON 輸出 (--json flag)</a:t>
-            </a:r>
-            <a:endParaRPr lang="en-US" sz="1200" dirty="0"/>
-          </a:p>
-          <a:p>
-            <a:pPr indent="0" marL="0">
-              <a:spcAft>
-                <a:spcPts val="200"/>
-              </a:spcAft>
-              <a:buNone/>
-            </a:pPr>
-            <a:r>
-              <a:rPr lang="en-US" sz="1200" dirty="0">
-                <a:solidFill>
-                  <a:srgbClr val="F4B400"/>
-                </a:solidFill>
-                <a:latin typeface="Consolas" pitchFamily="34" charset="0"/>
-                <a:ea typeface="Consolas" pitchFamily="34" charset="-122"/>
-                <a:cs typeface="Consolas" pitchFamily="34" charset="-120"/>
-              </a:rPr>
-              <a:t>$ java …Main check src/main/java arch.yaml --json</a:t>
-            </a:r>
-            <a:endParaRPr lang="en-US" sz="1200" dirty="0"/>
-          </a:p>
-          <a:p>
-            <a:pPr indent="0" marL="0">
-              <a:spcAft>
-                <a:spcPts val="200"/>
-              </a:spcAft>
-              <a:buNone/>
-            </a:pPr>
-            <a:r>
-              <a:rPr lang="en-US" sz="1200" dirty="0">
-                <a:solidFill>
-                  <a:srgbClr val="FFFFFF"/>
-                </a:solidFill>
-                <a:latin typeface="Consolas" pitchFamily="34" charset="0"/>
-                <a:ea typeface="Consolas" pitchFamily="34" charset="-122"/>
-                <a:cs typeface="Consolas" pitchFamily="34" charset="-120"/>
-              </a:rPr>
-              <a:t>{"checkedFiles":26,"violationCount":0,"suppressedCount":0,"violations":[]}</a:t>
-            </a:r>
-            <a:endParaRPr lang="en-US" sz="1200" dirty="0"/>
-          </a:p>
-          <a:p>
-            <a:pPr indent="0" marL="0">
-              <a:spcAft>
-                <a:spcPts val="200"/>
-              </a:spcAft>
-              <a:buNone/>
-            </a:pPr>
-            <a:endParaRPr lang="en-US" sz="1200" dirty="0"/>
-          </a:p>
-          <a:p>
-            <a:pPr indent="0" marL="0">
-              <a:spcAft>
-                <a:spcPts val="200"/>
-              </a:spcAft>
-              <a:buNone/>
-            </a:pPr>
-            <a:r>
-              <a:rPr lang="en-US" sz="1200" dirty="0">
-                <a:solidFill>
-                  <a:srgbClr val="CADCFC"/>
-                </a:solidFill>
-                <a:latin typeface="Consolas" pitchFamily="34" charset="0"/>
-                <a:ea typeface="Consolas" pitchFamily="34" charset="-122"/>
-                <a:cs typeface="Consolas" pitchFamily="34" charset="-120"/>
-              </a:rPr>
-              <a:t># picocli 自動產生的 help — 可從 CLI 探索可用 use case</a:t>
-            </a:r>
-            <a:endParaRPr lang="en-US" sz="1200" dirty="0"/>
-          </a:p>
-          <a:p>
-            <a:pPr indent="0" marL="0">
-              <a:spcAft>
-                <a:spcPts val="200"/>
-              </a:spcAft>
-              <a:buNone/>
-            </a:pPr>
-            <a:r>
-              <a:rPr lang="en-US" sz="1200" dirty="0">
-                <a:solidFill>
-                  <a:srgbClr val="F4B400"/>
-                </a:solidFill>
-                <a:latin typeface="Consolas" pitchFamily="34" charset="0"/>
-                <a:ea typeface="Consolas" pitchFamily="34" charset="-122"/>
-                <a:cs typeface="Consolas" pitchFamily="34" charset="-120"/>
-              </a:rPr>
-              <a:t>$ java …Main --help</a:t>
-            </a:r>
-            <a:endParaRPr lang="en-US" sz="1200" dirty="0"/>
-          </a:p>
-          <a:p>
-            <a:pPr indent="0" marL="0">
-              <a:spcAft>
-                <a:spcPts val="200"/>
-              </a:spcAft>
-              <a:buNone/>
-            </a:pPr>
-            <a:r>
-              <a:rPr lang="en-US" sz="1200" dirty="0">
-                <a:solidFill>
-                  <a:srgbClr val="FFFFFF"/>
-                </a:solidFill>
-                <a:latin typeface="Consolas" pitchFamily="34" charset="0"/>
-                <a:ea typeface="Consolas" pitchFamily="34" charset="-122"/>
-                <a:cs typeface="Consolas" pitchFamily="34" charset="-120"/>
-              </a:rPr>
-              <a:t>Usage: arch-checker [-hV] [COMMAND]</a:t>
-            </a:r>
-            <a:endParaRPr lang="en-US" sz="1200" dirty="0"/>
-          </a:p>
-          <a:p>
-            <a:pPr indent="0" marL="0">
-              <a:spcAft>
-                <a:spcPts val="200"/>
-              </a:spcAft>
-              <a:buNone/>
-            </a:pPr>
-            <a:r>
-              <a:rPr lang="en-US" sz="1200" dirty="0">
-                <a:solidFill>
-                  <a:srgbClr val="FFFFFF"/>
-                </a:solidFill>
-                <a:latin typeface="Consolas" pitchFamily="34" charset="0"/>
-                <a:ea typeface="Consolas" pitchFamily="34" charset="-122"/>
-                <a:cs typeface="Consolas" pitchFamily="34" charset="-120"/>
-              </a:rPr>
-              <a:t>A Fluent Architectural Style Compliance Tool for Java.</a:t>
-            </a:r>
-            <a:endParaRPr lang="en-US" sz="1200" dirty="0"/>
-          </a:p>
-          <a:p>
-            <a:pPr indent="0" marL="0">
-              <a:spcAft>
-                <a:spcPts val="200"/>
-              </a:spcAft>
-              <a:buNone/>
-            </a:pPr>
-            <a:r>
-              <a:rPr lang="en-US" sz="1200" dirty="0">
-                <a:solidFill>
-                  <a:srgbClr val="FFFFFF"/>
-                </a:solidFill>
-                <a:latin typeface="Consolas" pitchFamily="34" charset="0"/>
-                <a:ea typeface="Consolas" pitchFamily="34" charset="-122"/>
-                <a:cs typeface="Consolas" pitchFamily="34" charset="-120"/>
-              </a:rPr>
-              <a:t>  -h, --help     Show this help message and exit.</a:t>
-            </a:r>
-            <a:endParaRPr lang="en-US" sz="1200" dirty="0"/>
-          </a:p>
-          <a:p>
-            <a:pPr indent="0" marL="0">
-              <a:spcAft>
-                <a:spcPts val="200"/>
-              </a:spcAft>
-              <a:buNone/>
-            </a:pPr>
-            <a:r>
-              <a:rPr lang="en-US" sz="1200" dirty="0">
-                <a:solidFill>
-                  <a:srgbClr val="FFFFFF"/>
-                </a:solidFill>
-                <a:latin typeface="Consolas" pitchFamily="34" charset="0"/>
-                <a:ea typeface="Consolas" pitchFamily="34" charset="-122"/>
-                <a:cs typeface="Consolas" pitchFamily="34" charset="-120"/>
-              </a:rPr>
-              <a:t>  -V, --version  Print version information and exit.</a:t>
-            </a:r>
-            <a:endParaRPr lang="en-US" sz="1200" dirty="0"/>
-          </a:p>
-          <a:p>
-            <a:pPr indent="0" marL="0">
-              <a:spcAft>
-                <a:spcPts val="200"/>
-              </a:spcAft>
-              <a:buNone/>
-            </a:pPr>
-            <a:r>
-              <a:rPr lang="en-US" sz="1200" dirty="0">
-                <a:solidFill>
-                  <a:srgbClr val="FFFFFF"/>
-                </a:solidFill>
-                <a:latin typeface="Consolas" pitchFamily="34" charset="0"/>
-                <a:ea typeface="Consolas" pitchFamily="34" charset="-122"/>
-                <a:cs typeface="Consolas" pitchFamily="34" charset="-120"/>
-              </a:rPr>
-              <a:t>Commands:</a:t>
-            </a:r>
-            <a:endParaRPr lang="en-US" sz="1200" dirty="0"/>
-          </a:p>
-          <a:p>
-            <a:pPr indent="0" marL="0">
-              <a:spcAft>
-                <a:spcPts val="200"/>
-              </a:spcAft>
-              <a:buNone/>
-            </a:pPr>
-            <a:r>
-              <a:rPr lang="en-US" sz="1200" dirty="0">
-                <a:solidFill>
-                  <a:srgbClr val="FFFFFF"/>
-                </a:solidFill>
-                <a:latin typeface="Consolas" pitchFamily="34" charset="0"/>
-                <a:ea typeface="Consolas" pitchFamily="34" charset="-122"/>
-                <a:cs typeface="Consolas" pitchFamily="34" charset="-120"/>
-              </a:rPr>
-              <a:t>  check     Check architecture compliance against a Style Profile.</a:t>
-            </a:r>
-            <a:endParaRPr lang="en-US" sz="1200" dirty="0"/>
-          </a:p>
-          <a:p>
-            <a:pPr indent="0" marL="0">
-              <a:spcAft>
-                <a:spcPts val="200"/>
-              </a:spcAft>
-              <a:buNone/>
-            </a:pPr>
-            <a:r>
-              <a:rPr lang="en-US" sz="1200" dirty="0">
-                <a:solidFill>
-                  <a:srgbClr val="FFFFFF"/>
-                </a:solidFill>
-                <a:latin typeface="Consolas" pitchFamily="34" charset="0"/>
-                <a:ea typeface="Consolas" pitchFamily="34" charset="-122"/>
-                <a:cs typeface="Consolas" pitchFamily="34" charset="-120"/>
-              </a:rPr>
-              <a:t>  suppress  Mark a specific violation as 'known and accepted'.</a:t>
-            </a:r>
-            <a:endParaRPr lang="en-US" sz="1200" dirty="0"/>
-          </a:p>
-        </p:txBody>
-      </p:sp>
-      <p:sp>
-        <p:nvSpPr>
-          <p:cNvPr id="16" name="Text 14"/>
-          <p:cNvSpPr/>
-          <p:nvPr/>
-        </p:nvSpPr>
-        <p:spPr>
-          <a:xfrm>
-            <a:off x="502920" y="5943600"/>
-            <a:ext cx="11155680" cy="411480"/>
-          </a:xfrm>
-          <a:prstGeom prst="rect">
-            <a:avLst/>
-          </a:prstGeom>
-          <a:noFill/>
-          <a:ln/>
-        </p:spPr>
-        <p:txBody>
-          <a:bodyPr wrap="square" lIns="0" tIns="0" rIns="0" bIns="0" rtlCol="0" anchor="ctr"/>
-          <a:lstStyle/>
-          <a:p>
-            <a:pPr indent="0" marL="0">
+            <a:pPr algn="ctr" indent="0" marL="0">
               <a:buNone/>
             </a:pPr>
             <a:r>
@@ -24677,7 +23147,7 @@
                 <a:ea typeface="Microsoft JhengHei" pitchFamily="34" charset="-122"/>
                 <a:cs typeface="Microsoft JhengHei" pitchFamily="34" charset="-120"/>
               </a:rPr>
-              <a:t>FEA-04 多種報表格式 · Reporter polymorphism — 同一 Service 透過 strategy 產生 Console / JSON。</a:t>
+              <a:t>FEA-04 多種報表格式 · GRASP Polymorphism — 同一 ComplianceCheckService 透過 Reporter strategy 切換 Console / JSON。</a:t>
             </a:r>
             <a:endParaRPr lang="en-US" sz="1000" dirty="0"/>
           </a:p>

</xml_diff>